<commit_message>
Afegeix imatges al temari i a les diapositives de RA2 (AA1/AA2/AA3)
Segueix el mateix patro aplicat a RA1: incorpora imatges tant al
document de teoria (.md i .docx) com a la presentacio (.pptx) de cada
subtema, sense modificar el contingut textual ja existent.

AA1 (Protegint les dades): captura de titulars reals sobre ransomware.

AA2 (Sistemes d'emmagatzematge): diagrames de tots els nivells de RAID
(0, 1, 5, 6, 10) i la comparativa animada, mes fotografies/esquemes
reals de DAS, NAS i SAN.

AA3 (Copies de seguretat): esquema de la regla 3-2-1, comparativa
copia incremental/diferencial, esquemes GFS i Torres de Hanoi, i una
fotografia d'una clonadora forense.

Totes les imatges provenen del repositori font SMX-0226SI/Materials
(llicencia CC-BY-SA-4.0), ja utilitzat com a base de contingut d'aquestes
unitats.
Co-Authored-By: Claude Sonnet 5 <noreply@anthropic.com>
Claude-Session: https://claude.ai/code/session_01N3G5yf1RZohTyRwwRiXySq
</commit_message>
<xml_diff>
--- a/RA2 - Emmagatzematge i copies de seguretat/AA1 - Protegint les dades/RA2_AA1_Protegint_les_dades.pptx
+++ b/RA2 - Emmagatzematge i copies de seguretat/AA1 - Protegint les dades/RA2_AA1_Protegint_les_dades.pptx
@@ -8,6 +8,7 @@
     <p:sldId id="256" r:id="rId2"/>
     <p:sldId id="257" r:id="rId3"/>
     <p:sldId id="258" r:id="rId4"/>
+    <p:sldId id="269" r:id="rId20"/>
     <p:sldId id="259" r:id="rId5"/>
     <p:sldId id="260" r:id="rId6"/>
     <p:sldId id="261" r:id="rId7"/>
@@ -1962,6 +1963,10 @@
           </a:solidFill>
           <a:ln/>
         </p:spPr>
+        <p:txBody>
+          <a:bodyPr/>
+          <a:p/>
+        </p:txBody>
       </p:sp>
       <p:sp>
         <p:nvSpPr>
@@ -1982,6 +1987,10 @@
           </a:solidFill>
           <a:ln/>
         </p:spPr>
+        <p:txBody>
+          <a:bodyPr/>
+          <a:p/>
+        </p:txBody>
       </p:sp>
       <p:sp>
         <p:nvSpPr>
@@ -2368,7 +2377,7 @@
                 <a:ea typeface="Calibri" pitchFamily="34" charset="-122"/>
                 <a:cs typeface="Calibri" pitchFamily="34" charset="-120"/>
               </a:rPr>
-              <a:t>9</a:t>
+              <a:t>11</a:t>
             </a:r>
             <a:endParaRPr lang="en-US" sz="1100" dirty="0"/>
           </a:p>
@@ -2923,7 +2932,7 @@
                 <a:ea typeface="Calibri" pitchFamily="34" charset="-122"/>
                 <a:cs typeface="Calibri" pitchFamily="34" charset="-120"/>
               </a:rPr>
-              <a:t>10</a:t>
+              <a:t>12</a:t>
             </a:r>
             <a:endParaRPr lang="en-US" sz="1100" dirty="0"/>
           </a:p>
@@ -3654,7 +3663,7 @@
                 <a:ea typeface="Calibri" pitchFamily="34" charset="-122"/>
                 <a:cs typeface="Calibri" pitchFamily="34" charset="-120"/>
               </a:rPr>
-              <a:t>11</a:t>
+              <a:t>13</a:t>
             </a:r>
             <a:endParaRPr lang="en-US" sz="1100" dirty="0"/>
           </a:p>
@@ -4262,9 +4271,233 @@
                 <a:ea typeface="Calibri" pitchFamily="34" charset="-122"/>
                 <a:cs typeface="Calibri" pitchFamily="34" charset="-120"/>
               </a:rPr>
-              <a:t>12</a:t>
+              <a:t>14</a:t>
             </a:r>
             <a:endParaRPr lang="en-US" sz="1100" dirty="0"/>
+          </a:p>
+        </p:txBody>
+      </p:sp>
+    </p:spTree>
+  </p:cSld>
+  <p:clrMapOvr>
+    <a:masterClrMapping/>
+  </p:clrMapOvr>
+</p:sld>
+</file>
+
+<file path=ppt/slides/slide14.xml><?xml version="1.0" encoding="utf-8"?>
+<p:sld xmlns:a="http://schemas.openxmlformats.org/drawingml/2006/main" xmlns:p="http://schemas.openxmlformats.org/presentationml/2006/main" xmlns:r="http://schemas.openxmlformats.org/officeDocument/2006/relationships">
+  <p:cSld>
+    <p:bg>
+      <p:bgPr>
+        <a:solidFill>
+          <a:srgbClr val="F4F7F9"/>
+        </a:solidFill>
+        <a:effectLst/>
+      </p:bgPr>
+    </p:bg>
+    <p:spTree>
+      <p:nvGrpSpPr>
+        <p:cNvPr id="1" name=""/>
+        <p:cNvGrpSpPr/>
+        <p:nvPr/>
+      </p:nvGrpSpPr>
+      <p:grpSpPr/>
+      <p:sp>
+        <p:nvSpPr>
+          <p:cNvPr id="2" name="TextBox 1"/>
+          <p:cNvSpPr txBox="1"/>
+          <p:nvPr/>
+        </p:nvSpPr>
+        <p:spPr>
+          <a:xfrm>
+            <a:off x="548640" y="411480"/>
+            <a:ext cx="10515600" cy="320040"/>
+          </a:xfrm>
+          <a:prstGeom prst="rect">
+            <a:avLst/>
+          </a:prstGeom>
+          <a:noFill/>
+        </p:spPr>
+        <p:txBody>
+          <a:bodyPr wrap="square">
+            <a:spAutoFit/>
+          </a:bodyPr>
+          <a:lstStyle/>
+          <a:p>
+            <a:pPr algn="l"/>
+            <a:r>
+              <a:rPr sz="1300" b="1" i="0">
+                <a:solidFill>
+                  <a:srgbClr val="F2A541"/>
+                </a:solidFill>
+                <a:latin typeface="Calibri"/>
+              </a:rPr>
+              <a:t>UN CAS REAL</a:t>
+            </a:r>
+          </a:p>
+        </p:txBody>
+      </p:sp>
+      <p:sp>
+        <p:nvSpPr>
+          <p:cNvPr id="3" name="TextBox 2"/>
+          <p:cNvSpPr txBox="1"/>
+          <p:nvPr/>
+        </p:nvSpPr>
+        <p:spPr>
+          <a:xfrm>
+            <a:off x="548640" y="685800"/>
+            <a:ext cx="10972800" cy="822960"/>
+          </a:xfrm>
+          <a:prstGeom prst="rect">
+            <a:avLst/>
+          </a:prstGeom>
+          <a:noFill/>
+        </p:spPr>
+        <p:txBody>
+          <a:bodyPr wrap="square">
+            <a:spAutoFit/>
+          </a:bodyPr>
+          <a:lstStyle/>
+          <a:p>
+            <a:pPr algn="l"/>
+            <a:r>
+              <a:rPr sz="2800" b="1" i="0">
+                <a:solidFill>
+                  <a:srgbClr val="16242E"/>
+                </a:solidFill>
+                <a:latin typeface="Cambria"/>
+              </a:rPr>
+              <a:t>El ransomware, cada cop més present</a:t>
+            </a:r>
+          </a:p>
+        </p:txBody>
+      </p:sp>
+      <p:sp>
+        <p:nvSpPr>
+          <p:cNvPr id="4" name="TextBox 3"/>
+          <p:cNvSpPr txBox="1"/>
+          <p:nvPr/>
+        </p:nvSpPr>
+        <p:spPr>
+          <a:xfrm>
+            <a:off x="548640" y="1417320"/>
+            <a:ext cx="10789920" cy="548640"/>
+          </a:xfrm>
+          <a:prstGeom prst="rect">
+            <a:avLst/>
+          </a:prstGeom>
+          <a:noFill/>
+        </p:spPr>
+        <p:txBody>
+          <a:bodyPr wrap="square">
+            <a:spAutoFit/>
+          </a:bodyPr>
+          <a:lstStyle/>
+          <a:p>
+            <a:pPr algn="l"/>
+            <a:r>
+              <a:rPr sz="1300" b="0" i="0">
+                <a:solidFill>
+                  <a:srgbClr val="5B6B77"/>
+                </a:solidFill>
+                <a:latin typeface="Calibri"/>
+              </a:rPr>
+              <a:t>Titulars recents mostren l'abast real d'aquesta amenaça, també a Catalunya.</a:t>
+            </a:r>
+          </a:p>
+        </p:txBody>
+      </p:sp>
+      <p:pic>
+        <p:nvPicPr>
+          <p:cNvPr id="5" name="Picture 4" descr="ransomware.png"/>
+          <p:cNvPicPr>
+            <a:picLocks noChangeAspect="1"/>
+          </p:cNvPicPr>
+          <p:nvPr/>
+        </p:nvPicPr>
+        <p:blipFill>
+          <a:blip r:embed="rId2"/>
+          <a:stretch>
+            <a:fillRect/>
+          </a:stretch>
+        </p:blipFill>
+        <p:spPr>
+          <a:xfrm>
+            <a:off x="4721390" y="1920240"/>
+            <a:ext cx="2748914" cy="4114800"/>
+          </a:xfrm>
+          <a:prstGeom prst="rect">
+            <a:avLst/>
+          </a:prstGeom>
+        </p:spPr>
+      </p:pic>
+      <p:sp>
+        <p:nvSpPr>
+          <p:cNvPr id="6" name="TextBox 5"/>
+          <p:cNvSpPr txBox="1"/>
+          <p:nvPr/>
+        </p:nvSpPr>
+        <p:spPr>
+          <a:xfrm>
+            <a:off x="548640" y="6172200"/>
+            <a:ext cx="11064240" cy="457200"/>
+          </a:xfrm>
+          <a:prstGeom prst="rect">
+            <a:avLst/>
+          </a:prstGeom>
+          <a:noFill/>
+        </p:spPr>
+        <p:txBody>
+          <a:bodyPr wrap="square">
+            <a:spAutoFit/>
+          </a:bodyPr>
+          <a:lstStyle/>
+          <a:p>
+            <a:pPr algn="ctr"/>
+            <a:r>
+              <a:rPr sz="1200" b="0" i="1">
+                <a:solidFill>
+                  <a:srgbClr val="5B6B77"/>
+                </a:solidFill>
+                <a:latin typeface="Calibri"/>
+              </a:rPr>
+              <a:t>El ransomware xifra les dades de la víctima i en demana un rescat econòmic per desxifrar-les.</a:t>
+            </a:r>
+          </a:p>
+        </p:txBody>
+      </p:sp>
+      <p:sp>
+        <p:nvSpPr>
+          <p:cNvPr id="7" name="TextBox 6"/>
+          <p:cNvSpPr txBox="1"/>
+          <p:nvPr/>
+        </p:nvSpPr>
+        <p:spPr>
+          <a:xfrm>
+            <a:off x="11548872" y="6446520"/>
+            <a:ext cx="365760" cy="274320"/>
+          </a:xfrm>
+          <a:prstGeom prst="rect">
+            <a:avLst/>
+          </a:prstGeom>
+          <a:noFill/>
+        </p:spPr>
+        <p:txBody>
+          <a:bodyPr wrap="none">
+            <a:spAutoFit/>
+          </a:bodyPr>
+          <a:lstStyle/>
+          <a:p>
+            <a:pPr algn="r"/>
+            <a:r>
+              <a:rPr sz="1000">
+                <a:solidFill>
+                  <a:srgbClr val="5B6B77"/>
+                </a:solidFill>
+              </a:rPr>
+              <a:t>4</a:t>
+            </a:r>
           </a:p>
         </p:txBody>
       </p:sp>
@@ -4411,7 +4644,7 @@
                 <a:ea typeface="Calibri" pitchFamily="34" charset="-122"/>
                 <a:cs typeface="Calibri" pitchFamily="34" charset="-120"/>
               </a:rPr>
-              <a:t>1</a:t>
+              <a:t>2</a:t>
             </a:r>
             <a:endParaRPr lang="en-US" sz="1100" dirty="0"/>
           </a:p>
@@ -4450,6 +4683,10 @@
             </a:outerShdw>
           </a:effectLst>
         </p:spPr>
+        <p:txBody>
+          <a:bodyPr/>
+          <a:p/>
+        </p:txBody>
       </p:sp>
       <p:sp>
         <p:nvSpPr>
@@ -4470,6 +4707,10 @@
           </a:solidFill>
           <a:ln/>
         </p:spPr>
+        <p:txBody>
+          <a:bodyPr/>
+          <a:p/>
+        </p:txBody>
       </p:sp>
       <p:pic>
         <p:nvPicPr>
@@ -4609,6 +4850,10 @@
             </a:outerShdw>
           </a:effectLst>
         </p:spPr>
+        <p:txBody>
+          <a:bodyPr/>
+          <a:p/>
+        </p:txBody>
       </p:sp>
       <p:sp>
         <p:nvSpPr>
@@ -4629,6 +4874,10 @@
           </a:solidFill>
           <a:ln/>
         </p:spPr>
+        <p:txBody>
+          <a:bodyPr/>
+          <a:p/>
+        </p:txBody>
       </p:sp>
       <p:pic>
         <p:nvPicPr>
@@ -4768,6 +5017,10 @@
             </a:outerShdw>
           </a:effectLst>
         </p:spPr>
+        <p:txBody>
+          <a:bodyPr/>
+          <a:p/>
+        </p:txBody>
       </p:sp>
       <p:sp>
         <p:nvSpPr>
@@ -4788,6 +5041,10 @@
           </a:solidFill>
           <a:ln/>
         </p:spPr>
+        <p:txBody>
+          <a:bodyPr/>
+          <a:p/>
+        </p:txBody>
       </p:sp>
       <p:pic>
         <p:nvPicPr>
@@ -5223,7 +5480,7 @@
                 <a:ea typeface="Calibri" pitchFamily="34" charset="-122"/>
                 <a:cs typeface="Calibri" pitchFamily="34" charset="-120"/>
               </a:rPr>
-              <a:t>2</a:t>
+              <a:t>3</a:t>
             </a:r>
             <a:endParaRPr lang="en-US" sz="1100" dirty="0"/>
           </a:p>
@@ -5372,7 +5629,7 @@
                 <a:ea typeface="Calibri" pitchFamily="34" charset="-122"/>
                 <a:cs typeface="Calibri" pitchFamily="34" charset="-120"/>
               </a:rPr>
-              <a:t>3</a:t>
+              <a:t>5</a:t>
             </a:r>
             <a:endParaRPr lang="en-US" sz="1100" dirty="0"/>
           </a:p>
@@ -5703,7 +5960,7 @@
                 <a:ea typeface="Calibri" pitchFamily="34" charset="-122"/>
                 <a:cs typeface="Calibri" pitchFamily="34" charset="-120"/>
               </a:rPr>
-              <a:t>4</a:t>
+              <a:t>6</a:t>
             </a:r>
             <a:endParaRPr lang="en-US" sz="1100" dirty="0"/>
           </a:p>
@@ -6170,7 +6427,7 @@
                 <a:ea typeface="Calibri" pitchFamily="34" charset="-122"/>
                 <a:cs typeface="Calibri" pitchFamily="34" charset="-120"/>
               </a:rPr>
-              <a:t>5</a:t>
+              <a:t>7</a:t>
             </a:r>
             <a:endParaRPr lang="en-US" sz="1100" dirty="0"/>
           </a:p>
@@ -6725,7 +6982,7 @@
                 <a:ea typeface="Calibri" pitchFamily="34" charset="-122"/>
                 <a:cs typeface="Calibri" pitchFamily="34" charset="-120"/>
               </a:rPr>
-              <a:t>6</a:t>
+              <a:t>8</a:t>
             </a:r>
             <a:endParaRPr lang="en-US" sz="1100" dirty="0"/>
           </a:p>
@@ -7032,7 +7289,7 @@
                 <a:ea typeface="Calibri" pitchFamily="34" charset="-122"/>
                 <a:cs typeface="Calibri" pitchFamily="34" charset="-120"/>
               </a:rPr>
-              <a:t>7</a:t>
+              <a:t>9</a:t>
             </a:r>
             <a:endParaRPr lang="en-US" sz="1100" dirty="0"/>
           </a:p>
@@ -7658,7 +7915,7 @@
                 <a:ea typeface="Calibri" pitchFamily="34" charset="-122"/>
                 <a:cs typeface="Calibri" pitchFamily="34" charset="-120"/>
               </a:rPr>
-              <a:t>8</a:t>
+              <a:t>10</a:t>
             </a:r>
             <a:endParaRPr lang="en-US" sz="1100" dirty="0"/>
           </a:p>

</xml_diff>

<commit_message>
RA2: afegeix hipervincles a les fonts citades (sense canviar contingut)
Recupera els enllaços del repositori SMX-0226SI/Materials (NF2) que
s'havien perdut en adaptar el material: només s'enllaça text ja existent,
sense modificar-ne cap paraula. Aplicat als temaris (.md i .docx), als
exercicis i pràctiques (.docx i .pdf) i a les presentacions (.pptx).

Co-Authored-By: Claude Opus 5.5 <noreply@anthropic.com>
Claude-Session: https://claude.ai/code/session_01BodJZ9PsepvknsFhsdyYkP
</commit_message>
<xml_diff>
--- a/RA2 - Emmagatzematge i copies de seguretat/AA1 - Protegint les dades/RA2_AA1_Protegint_les_dades.pptx
+++ b/RA2 - Emmagatzematge i copies de seguretat/AA1 - Protegint les dades/RA2_AA1_Protegint_les_dades.pptx
@@ -2244,6 +2244,317 @@
 
 <file path=ppt/slides/slide10.xml><?xml version="1.0" encoding="utf-8"?>
 <p:sld xmlns:a="http://schemas.openxmlformats.org/drawingml/2006/main" xmlns:r="http://schemas.openxmlformats.org/officeDocument/2006/relationships" xmlns:p="http://schemas.openxmlformats.org/presentationml/2006/main">
+  <p:cSld name="Slide 9">
+    <p:bg>
+      <p:bgPr>
+        <a:solidFill>
+          <a:srgbClr val="F4F7F9"/>
+        </a:solidFill>
+      </p:bgPr>
+    </p:bg>
+    <p:spTree>
+      <p:nvGrpSpPr>
+        <p:cNvPr id="1" name=""/>
+        <p:cNvGrpSpPr/>
+        <p:nvPr/>
+      </p:nvGrpSpPr>
+      <p:grpSpPr>
+        <a:xfrm>
+          <a:off x="0" y="0"/>
+          <a:ext cx="0" cy="0"/>
+          <a:chOff x="0" y="0"/>
+          <a:chExt cx="0" cy="0"/>
+        </a:xfrm>
+      </p:grpSpPr>
+      <p:sp>
+        <p:nvSpPr>
+          <p:cNvPr id="2" name="Text 0"/>
+          <p:cNvSpPr txBox="1"/>
+          <p:nvPr/>
+        </p:nvSpPr>
+        <p:spPr>
+          <a:xfrm>
+            <a:off x="548640" y="457200"/>
+            <a:ext cx="9144000" cy="365760"/>
+          </a:xfrm>
+          <a:prstGeom prst="rect">
+            <a:avLst/>
+          </a:prstGeom>
+          <a:noFill/>
+          <a:ln/>
+        </p:spPr>
+        <p:txBody>
+          <a:bodyPr wrap="square" lIns="0" tIns="0" rIns="0" bIns="0" rtlCol="0" anchor="ctr"/>
+          <a:lstStyle/>
+          <a:p>
+            <a:pPr indent="0" marL="0">
+              <a:buNone/>
+            </a:pPr>
+            <a:r>
+              <a:rPr lang="en-US" sz="1300" b="1" spc="200" kern="0" dirty="0">
+                <a:solidFill>
+                  <a:srgbClr val="F2A541"/>
+                </a:solidFill>
+                <a:latin typeface="Calibri" pitchFamily="34" charset="0"/>
+                <a:ea typeface="Calibri" pitchFamily="34" charset="-122"/>
+                <a:cs typeface="Calibri" pitchFamily="34" charset="-120"/>
+              </a:rPr>
+              <a:t>ESTÀNDARD DE REFERÈNCIA</a:t>
+            </a:r>
+            <a:endParaRPr lang="en-US" sz="1300" dirty="0"/>
+          </a:p>
+        </p:txBody>
+      </p:sp>
+      <p:sp>
+        <p:nvSpPr>
+          <p:cNvPr id="3" name="Text 1"/>
+          <p:cNvSpPr txBox="1"/>
+          <p:nvPr/>
+        </p:nvSpPr>
+        <p:spPr>
+          <a:xfrm>
+            <a:off x="548640" y="822960"/>
+            <a:ext cx="10789920" cy="640080"/>
+          </a:xfrm>
+          <a:prstGeom prst="rect">
+            <a:avLst/>
+          </a:prstGeom>
+          <a:noFill/>
+          <a:ln/>
+        </p:spPr>
+        <p:txBody>
+          <a:bodyPr wrap="square" lIns="0" tIns="0" rIns="0" bIns="0" rtlCol="0" anchor="ctr"/>
+          <a:lstStyle/>
+          <a:p>
+            <a:pPr indent="0" marL="0">
+              <a:buNone/>
+            </a:pPr>
+            <a:r>
+              <a:rPr lang="en-US" sz="2800" b="1" dirty="0">
+                <a:solidFill>
+                  <a:srgbClr val="16242E"/>
+                </a:solidFill>
+                <a:latin typeface="Cambria" pitchFamily="34" charset="0"/>
+                <a:ea typeface="Cambria" pitchFamily="34" charset="-122"/>
+                <a:cs typeface="Cambria" pitchFamily="34" charset="-120"/>
+              </a:rPr>
+              <a:t>DoD 5220.22-M</a:t>
+            </a:r>
+            <a:endParaRPr lang="en-US" sz="2800" dirty="0"/>
+          </a:p>
+        </p:txBody>
+      </p:sp>
+      <p:sp>
+        <p:nvSpPr>
+          <p:cNvPr id="4" name="Text 2"/>
+          <p:cNvSpPr txBox="1"/>
+          <p:nvPr/>
+        </p:nvSpPr>
+        <p:spPr>
+          <a:xfrm>
+            <a:off x="11551615" y="6446520"/>
+            <a:ext cx="457200" cy="274320"/>
+          </a:xfrm>
+          <a:prstGeom prst="rect">
+            <a:avLst/>
+          </a:prstGeom>
+          <a:noFill/>
+          <a:ln/>
+        </p:spPr>
+        <p:txBody>
+          <a:bodyPr wrap="square" lIns="0" tIns="0" rIns="0" bIns="0" rtlCol="0" anchor="ctr"/>
+          <a:lstStyle/>
+          <a:p>
+            <a:pPr algn="r" indent="0" marL="0">
+              <a:buNone/>
+            </a:pPr>
+            <a:r>
+              <a:rPr lang="en-US" sz="1100" dirty="0">
+                <a:solidFill>
+                  <a:srgbClr val="5B6B77"/>
+                </a:solidFill>
+                <a:latin typeface="Calibri" pitchFamily="34" charset="0"/>
+                <a:ea typeface="Calibri" pitchFamily="34" charset="-122"/>
+                <a:cs typeface="Calibri" pitchFamily="34" charset="-120"/>
+              </a:rPr>
+              <a:t>10</a:t>
+            </a:r>
+            <a:endParaRPr lang="en-US" sz="1100" dirty="0"/>
+          </a:p>
+        </p:txBody>
+      </p:sp>
+      <p:sp>
+        <p:nvSpPr>
+          <p:cNvPr id="5" name="Shape 3"/>
+          <p:cNvSpPr/>
+          <p:nvPr/>
+        </p:nvSpPr>
+        <p:spPr>
+          <a:xfrm>
+            <a:off x="914400" y="2103120"/>
+            <a:ext cx="10332720" cy="1645920"/>
+          </a:xfrm>
+          <a:prstGeom prst="roundRect">
+            <a:avLst>
+              <a:gd name="adj" fmla="val 5556"/>
+            </a:avLst>
+          </a:prstGeom>
+          <a:solidFill>
+            <a:srgbClr val="0B1B29"/>
+          </a:solidFill>
+          <a:ln/>
+        </p:spPr>
+        <p:txBody>
+          <a:bodyPr/>
+          <a:p/>
+        </p:txBody>
+      </p:sp>
+      <p:pic>
+        <p:nvPicPr>
+          <p:cNvPr id="6" name="Image 0" descr="/tmp/claude-0/-home-user-SMX-0226-Seguretat-Informatica/cec25c9b-7e93-584a-a64a-196540977a59/scratchpad/build/icons/checkcircle_F2A541.png">    </p:cNvPr>
+          <p:cNvPicPr>
+            <a:picLocks noChangeAspect="1"/>
+          </p:cNvPicPr>
+          <p:nvPr/>
+        </p:nvPicPr>
+        <p:blipFill>
+          <a:blip r:embed="rId1"/>
+          <a:stretch>
+            <a:fillRect/>
+          </a:stretch>
+        </p:blipFill>
+        <p:spPr>
+          <a:xfrm>
+            <a:off x="1188720" y="2697480"/>
+            <a:ext cx="457200" cy="457200"/>
+          </a:xfrm>
+          <a:prstGeom prst="rect">
+            <a:avLst/>
+          </a:prstGeom>
+        </p:spPr>
+      </p:pic>
+      <p:sp>
+        <p:nvSpPr>
+          <p:cNvPr id="7" name="Text 4"/>
+          <p:cNvSpPr txBox="1"/>
+          <p:nvPr/>
+        </p:nvSpPr>
+        <p:spPr>
+          <a:xfrm>
+            <a:off x="1828800" y="2240280"/>
+            <a:ext cx="9144000" cy="1371600"/>
+          </a:xfrm>
+          <a:prstGeom prst="rect">
+            <a:avLst/>
+          </a:prstGeom>
+          <a:noFill/>
+          <a:ln/>
+        </p:spPr>
+        <p:txBody>
+          <a:bodyPr wrap="square" lIns="0" tIns="0" rIns="0" bIns="0" rtlCol="0" anchor="ctr"/>
+          <a:lstStyle/>
+          <a:p>
+            <a:pPr indent="0" marL="0">
+              <a:lnSpc>
+                <a:spcPts val="1800"/>
+              </a:lnSpc>
+              <a:buNone/>
+            </a:pPr>
+            <a:r>
+              <a:rPr lang="en-US" sz="1350" i="1" dirty="0">
+                <a:solidFill>
+                  <a:srgbClr val="FFFFFF"/>
+                </a:solidFill>
+                <a:latin typeface="Calibri" pitchFamily="34" charset="0"/>
+                <a:ea typeface="Calibri" pitchFamily="34" charset="-122"/>
+                <a:cs typeface="Calibri" pitchFamily="34" charset="-120"/>
+              </a:rPr>
+              <a:t>El Departament de Defensa dels Estats Units recomana un procediment de sobrescriptura en 3 passades: 1) sobreescriure una vegada amb zeros; 2) sobreescriure tres vegades amb dades aleatòries; 3) sobreescriure una vegada amb uns. Aquesta és l'estratègia que recomana l'estàndard DoD 5220.22-M.</a:t>
+            </a:r>
+            <a:endParaRPr lang="en-US" sz="1350" dirty="0"/>
+          </a:p>
+        </p:txBody>
+      </p:sp>
+      <p:sp>
+        <p:nvSpPr>
+          <p:cNvPr id="8" name="Text 5"/>
+          <p:cNvSpPr txBox="1"/>
+          <p:nvPr/>
+        </p:nvSpPr>
+        <p:spPr>
+          <a:xfrm>
+            <a:off x="914400" y="4114800"/>
+            <a:ext cx="10332720" cy="1645920"/>
+          </a:xfrm>
+          <a:prstGeom prst="rect">
+            <a:avLst/>
+          </a:prstGeom>
+          <a:noFill/>
+          <a:ln/>
+        </p:spPr>
+        <p:txBody>
+          <a:bodyPr wrap="square" lIns="0" tIns="0" rIns="0" bIns="0" rtlCol="0" anchor="t"/>
+          <a:lstStyle/>
+          <a:p>
+            <a:pPr marL="342900" indent="-342900">
+              <a:lnSpc>
+                <a:spcPts val="2000"/>
+              </a:lnSpc>
+              <a:spcAft>
+                <a:spcPts val="1000"/>
+              </a:spcAft>
+              <a:buSzPct val="100000"/>
+              <a:buChar char="▪"/>
+            </a:pPr>
+            <a:r>
+              <a:rPr lang="en-US" sz="1500" dirty="0">
+                <a:solidFill>
+                  <a:srgbClr val="16242E"/>
+                </a:solidFill>
+                <a:latin typeface="Calibri" pitchFamily="34" charset="0"/>
+                <a:ea typeface="Calibri" pitchFamily="34" charset="-122"/>
+                <a:cs typeface="Calibri" pitchFamily="34" charset="-120"/>
+              </a:rPr>
+              <a:t>Un simple "Esborra" o un format ràpid NO elimina realment les dades: només marca l'espai com a disponible.</a:t>
+            </a:r>
+            <a:endParaRPr lang="en-US" sz="1500" dirty="0"/>
+          </a:p>
+          <a:p>
+            <a:pPr marL="342900" indent="-342900">
+              <a:lnSpc>
+                <a:spcPts val="2000"/>
+              </a:lnSpc>
+              <a:spcAft>
+                <a:spcPts val="1000"/>
+              </a:spcAft>
+              <a:buSzPct val="100000"/>
+              <a:buChar char="▪"/>
+            </a:pPr>
+            <a:r>
+              <a:rPr lang="en-US" sz="1500" dirty="0">
+                <a:solidFill>
+                  <a:srgbClr val="16242E"/>
+                </a:solidFill>
+                <a:latin typeface="Calibri" pitchFamily="34" charset="0"/>
+                <a:ea typeface="Calibri" pitchFamily="34" charset="-122"/>
+                <a:cs typeface="Calibri" pitchFamily="34" charset="-120"/>
+              </a:rPr>
+              <a:t>La sobrescriptura no es pot aplicar a dispositius d'un sol ús, com un DVD gravat: en aquest cas només queda la destrucció física.</a:t>
+            </a:r>
+            <a:endParaRPr lang="en-US" sz="1500" dirty="0"/>
+          </a:p>
+        </p:txBody>
+      </p:sp>
+    </p:spTree>
+  </p:cSld>
+  <p:clrMapOvr>
+    <a:masterClrMapping/>
+  </p:clrMapOvr>
+</p:sld>
+</file>
+
+<file path=ppt/slides/slide11.xml><?xml version="1.0" encoding="utf-8"?>
+<p:sld xmlns:a="http://schemas.openxmlformats.org/drawingml/2006/main" xmlns:r="http://schemas.openxmlformats.org/officeDocument/2006/relationships" xmlns:p="http://schemas.openxmlformats.org/presentationml/2006/main">
   <p:cSld name="Slide 10">
     <p:bg>
       <p:bgPr>
@@ -2416,6 +2727,10 @@
             </a:outerShdw>
           </a:effectLst>
         </p:spPr>
+        <p:txBody>
+          <a:bodyPr/>
+          <a:p/>
+        </p:txBody>
       </p:sp>
       <p:sp>
         <p:nvSpPr>
@@ -2436,6 +2751,10 @@
           </a:solidFill>
           <a:ln/>
         </p:spPr>
+        <p:txBody>
+          <a:bodyPr/>
+          <a:p/>
+        </p:txBody>
       </p:sp>
       <p:pic>
         <p:nvPicPr>
@@ -2575,6 +2894,10 @@
             </a:outerShdw>
           </a:effectLst>
         </p:spPr>
+        <p:txBody>
+          <a:bodyPr/>
+          <a:p/>
+        </p:txBody>
       </p:sp>
       <p:sp>
         <p:nvSpPr>
@@ -2595,6 +2918,10 @@
           </a:solidFill>
           <a:ln/>
         </p:spPr>
+        <p:txBody>
+          <a:bodyPr/>
+          <a:p/>
+        </p:txBody>
       </p:sp>
       <p:pic>
         <p:nvPicPr>
@@ -2695,7 +3022,30 @@
                 <a:ea typeface="Calibri" pitchFamily="34" charset="-122"/>
                 <a:cs typeface="Calibri" pitchFamily="34" charset="-120"/>
               </a:rPr>
-              <a:t>El reportatge "Copy Machines, a Security Risk?" (CBS News) va destapar que fotocopiadores donades de baixa o revenudes conservaven milers de documents confidencials sense que ningú ho sabés.</a:t>
+              <a:t>El reportatge </a:t>
+            </a:r>
+            <a:r>
+              <a:rPr lang="en-US" sz="1350" dirty="0">
+                <a:solidFill>
+                  <a:srgbClr val="5B6B77"/>
+                </a:solidFill>
+                <a:latin typeface="Calibri" pitchFamily="34" charset="0"/>
+                <a:ea typeface="Calibri" pitchFamily="34" charset="-122"/>
+                <a:cs typeface="Calibri" pitchFamily="34" charset="-120"/>
+                <a:hlinkClick r:id="rId6"/>
+              </a:rPr>
+              <a:t>"Copy Machines, a Security Risk?"</a:t>
+            </a:r>
+            <a:r>
+              <a:rPr lang="en-US" sz="1350" dirty="0">
+                <a:solidFill>
+                  <a:srgbClr val="5B6B77"/>
+                </a:solidFill>
+                <a:latin typeface="Calibri" pitchFamily="34" charset="0"/>
+                <a:ea typeface="Calibri" pitchFamily="34" charset="-122"/>
+                <a:cs typeface="Calibri" pitchFamily="34" charset="-120"/>
+              </a:rPr>
+              <a:t> (CBS News) va destapar que fotocopiadores donades de baixa o revenudes conservaven milers de documents confidencials sense que ningú ho sabés.</a:t>
             </a:r>
             <a:endParaRPr lang="en-US" sz="1350" dirty="0"/>
           </a:p>
@@ -2722,6 +3072,10 @@
           </a:solidFill>
           <a:ln/>
         </p:spPr>
+        <p:txBody>
+          <a:bodyPr/>
+          <a:p/>
+        </p:txBody>
       </p:sp>
       <p:pic>
         <p:nvPicPr>
@@ -2797,7 +3151,7 @@
 </p:sld>
 </file>
 
-<file path=ppt/slides/slide11.xml><?xml version="1.0" encoding="utf-8"?>
+<file path=ppt/slides/slide12.xml><?xml version="1.0" encoding="utf-8"?>
 <p:sld xmlns:a="http://schemas.openxmlformats.org/drawingml/2006/main" xmlns:r="http://schemas.openxmlformats.org/officeDocument/2006/relationships" xmlns:p="http://schemas.openxmlformats.org/presentationml/2006/main">
   <p:cSld name="Slide 11">
     <p:bg>
@@ -2971,6 +3325,10 @@
             </a:outerShdw>
           </a:effectLst>
         </p:spPr>
+        <p:txBody>
+          <a:bodyPr/>
+          <a:p/>
+        </p:txBody>
       </p:sp>
       <p:sp>
         <p:nvSpPr>
@@ -2991,6 +3349,10 @@
           </a:solidFill>
           <a:ln/>
         </p:spPr>
+        <p:txBody>
+          <a:bodyPr/>
+          <a:p/>
+        </p:txBody>
       </p:sp>
       <p:pic>
         <p:nvPicPr>
@@ -3130,6 +3492,10 @@
             </a:outerShdw>
           </a:effectLst>
         </p:spPr>
+        <p:txBody>
+          <a:bodyPr/>
+          <a:p/>
+        </p:txBody>
       </p:sp>
       <p:sp>
         <p:nvSpPr>
@@ -3150,6 +3516,10 @@
           </a:solidFill>
           <a:ln/>
         </p:spPr>
+        <p:txBody>
+          <a:bodyPr/>
+          <a:p/>
+        </p:txBody>
       </p:sp>
       <p:pic>
         <p:nvPicPr>
@@ -3289,6 +3659,10 @@
             </a:outerShdw>
           </a:effectLst>
         </p:spPr>
+        <p:txBody>
+          <a:bodyPr/>
+          <a:p/>
+        </p:txBody>
       </p:sp>
       <p:sp>
         <p:nvSpPr>
@@ -3309,6 +3683,10 @@
           </a:solidFill>
           <a:ln/>
         </p:spPr>
+        <p:txBody>
+          <a:bodyPr/>
+          <a:p/>
+        </p:txBody>
       </p:sp>
       <p:pic>
         <p:nvPicPr>
@@ -3423,7 +3801,7 @@
 </p:sld>
 </file>
 
-<file path=ppt/slides/slide12.xml><?xml version="1.0" encoding="utf-8"?>
+<file path=ppt/slides/slide13.xml><?xml version="1.0" encoding="utf-8"?>
 <p:sld xmlns:a="http://schemas.openxmlformats.org/drawingml/2006/main" xmlns:r="http://schemas.openxmlformats.org/officeDocument/2006/relationships" xmlns:p="http://schemas.openxmlformats.org/presentationml/2006/main">
   <p:cSld name="Slide 12">
     <p:bg>
@@ -3677,7 +4055,7 @@
 </p:sld>
 </file>
 
-<file path=ppt/slides/slide13.xml><?xml version="1.0" encoding="utf-8"?>
+<file path=ppt/slides/slide14.xml><?xml version="1.0" encoding="utf-8"?>
 <p:sld xmlns:a="http://schemas.openxmlformats.org/drawingml/2006/main" xmlns:r="http://schemas.openxmlformats.org/officeDocument/2006/relationships" xmlns:p="http://schemas.openxmlformats.org/presentationml/2006/main">
   <p:cSld name="Slide 13">
     <p:bg>
@@ -3878,7 +4256,19 @@
                 <a:ea typeface="Calibri" pitchFamily="34" charset="-122"/>
                 <a:cs typeface="Calibri" pitchFamily="34" charset="-120"/>
               </a:rPr>
-              <a:t>Repositori "Materials" (GitHub, SMX-0226SI) · Carlos Alonso Martínez, Escola Pia de Mataró · Llicència CC-BY-SA-4.0 — github.com/SMX-0226SI/Materials/blob/main/NF2/AA1-ProtegintDades.md</a:t>
+              <a:t>Repositori "Materials" (GitHub, SMX-0226SI) · Carlos Alonso Martínez, Escola Pia de Mataró · Llicència CC-BY-SA-4.0 — </a:t>
+            </a:r>
+            <a:r>
+              <a:rPr lang="en-US" sz="1150" dirty="0">
+                <a:solidFill>
+                  <a:srgbClr val="5B6B77"/>
+                </a:solidFill>
+                <a:latin typeface="Calibri" pitchFamily="34" charset="0"/>
+                <a:ea typeface="Calibri" pitchFamily="34" charset="-122"/>
+                <a:cs typeface="Calibri" pitchFamily="34" charset="-120"/>
+                <a:hlinkClick r:id="rId7"/>
+              </a:rPr>
+              <a:t>github.com/SMX-0226SI/Materials/blob/main/NF2/AA1-ProtegintDades.md</a:t>
             </a:r>
             <a:endParaRPr lang="en-US" sz="1150" dirty="0"/>
           </a:p>
@@ -3983,7 +4373,19 @@
                 <a:ea typeface="Calibri" pitchFamily="34" charset="-122"/>
                 <a:cs typeface="Calibri" pitchFamily="34" charset="-120"/>
               </a:rPr>
-              <a:t>IONOS Digital Guide — "La importancia de contar con un disaster recovery plan"</a:t>
+              <a:t>IONOS Digital Guide — </a:t>
+            </a:r>
+            <a:r>
+              <a:rPr lang="en-US" sz="1150" dirty="0">
+                <a:solidFill>
+                  <a:srgbClr val="5B6B77"/>
+                </a:solidFill>
+                <a:latin typeface="Calibri" pitchFamily="34" charset="0"/>
+                <a:ea typeface="Calibri" pitchFamily="34" charset="-122"/>
+                <a:cs typeface="Calibri" pitchFamily="34" charset="-120"/>
+                <a:hlinkClick r:id="rId8"/>
+              </a:rPr>
+              <a:t>"La importancia de contar con un disaster recovery plan"</a:t>
             </a:r>
             <a:endParaRPr lang="en-US" sz="1150" dirty="0"/>
           </a:p>
@@ -4088,7 +4490,30 @@
                 <a:ea typeface="Calibri" pitchFamily="34" charset="-122"/>
                 <a:cs typeface="Calibri" pitchFamily="34" charset="-120"/>
               </a:rPr>
-              <a:t>PCMag — "Many Used Hard Drives Sold on eBay Still Contain Leftover Data" (2019)</a:t>
+              <a:t>PCMag — </a:t>
+            </a:r>
+            <a:r>
+              <a:rPr lang="en-US" sz="1150" dirty="0">
+                <a:solidFill>
+                  <a:srgbClr val="5B6B77"/>
+                </a:solidFill>
+                <a:latin typeface="Calibri" pitchFamily="34" charset="0"/>
+                <a:ea typeface="Calibri" pitchFamily="34" charset="-122"/>
+                <a:cs typeface="Calibri" pitchFamily="34" charset="-120"/>
+                <a:hlinkClick r:id="rId9"/>
+              </a:rPr>
+              <a:t>"Many Used Hard Drives Sold on eBay Still Contain Leftover Data"</a:t>
+            </a:r>
+            <a:r>
+              <a:rPr lang="en-US" sz="1150" dirty="0">
+                <a:solidFill>
+                  <a:srgbClr val="5B6B77"/>
+                </a:solidFill>
+                <a:latin typeface="Calibri" pitchFamily="34" charset="0"/>
+                <a:ea typeface="Calibri" pitchFamily="34" charset="-122"/>
+                <a:cs typeface="Calibri" pitchFamily="34" charset="-120"/>
+              </a:rPr>
+              <a:t> (2019)</a:t>
             </a:r>
             <a:endParaRPr lang="en-US" sz="1150" dirty="0"/>
           </a:p>
@@ -4192,39 +4617,12 @@
                 <a:latin typeface="Calibri" pitchFamily="34" charset="0"/>
                 <a:ea typeface="Calibri" pitchFamily="34" charset="-122"/>
                 <a:cs typeface="Calibri" pitchFamily="34" charset="-120"/>
-              </a:rPr>
-              <a:t>"Copy Machines, a Security Risk?" — reportatge disponible a YouTube</a:t>
-            </a:r>
-            <a:endParaRPr lang="en-US" sz="1150" dirty="0"/>
-          </a:p>
-        </p:txBody>
-      </p:sp>
-      <p:sp>
-        <p:nvSpPr>
-          <p:cNvPr id="16" name="Text 10"/>
-          <p:cNvSpPr txBox="1"/>
-          <p:nvPr/>
-        </p:nvSpPr>
-        <p:spPr>
-          <a:xfrm>
-            <a:off x="640080" y="6217920"/>
-            <a:ext cx="10058400" cy="365760"/>
-          </a:xfrm>
-          <a:prstGeom prst="rect">
-            <a:avLst/>
-          </a:prstGeom>
-          <a:noFill/>
-          <a:ln/>
-        </p:spPr>
-        <p:txBody>
-          <a:bodyPr wrap="square" lIns="0" tIns="0" rIns="0" bIns="0" rtlCol="0" anchor="ctr"/>
-          <a:lstStyle/>
-          <a:p>
-            <a:pPr indent="0" marL="0">
-              <a:buNone/>
-            </a:pPr>
-            <a:r>
-              <a:rPr lang="en-US" sz="1050" i="1" dirty="0">
+                <a:hlinkClick r:id="rId10"/>
+              </a:rPr>
+              <a:t>"Copy Machines, a Security Risk?"</a:t>
+            </a:r>
+            <a:r>
+              <a:rPr lang="en-US" sz="1150" dirty="0">
                 <a:solidFill>
                   <a:srgbClr val="5B6B77"/>
                 </a:solidFill>
@@ -4232,22 +4630,22 @@
                 <a:ea typeface="Calibri" pitchFamily="34" charset="-122"/>
                 <a:cs typeface="Calibri" pitchFamily="34" charset="-120"/>
               </a:rPr>
-              <a:t>Llicència Creative Commons BY-NC-SA · Institut Obert de Catalunya, 2011 (materials adaptats i ampliats)</a:t>
-            </a:r>
-            <a:endParaRPr lang="en-US" sz="1050" dirty="0"/>
-          </a:p>
-        </p:txBody>
-      </p:sp>
-      <p:sp>
-        <p:nvSpPr>
-          <p:cNvPr id="17" name="Text 11"/>
-          <p:cNvSpPr txBox="1"/>
-          <p:nvPr/>
-        </p:nvSpPr>
-        <p:spPr>
-          <a:xfrm>
-            <a:off x="11551615" y="6446520"/>
-            <a:ext cx="457200" cy="274320"/>
+              <a:t> — reportatge disponible a YouTube</a:t>
+            </a:r>
+            <a:endParaRPr lang="en-US" sz="1150" dirty="0"/>
+          </a:p>
+        </p:txBody>
+      </p:sp>
+      <p:sp>
+        <p:nvSpPr>
+          <p:cNvPr id="16" name="Text 10"/>
+          <p:cNvSpPr txBox="1"/>
+          <p:nvPr/>
+        </p:nvSpPr>
+        <p:spPr>
+          <a:xfrm>
+            <a:off x="640080" y="6217920"/>
+            <a:ext cx="10058400" cy="365760"/>
           </a:xfrm>
           <a:prstGeom prst="rect">
             <a:avLst/>
@@ -4259,11 +4657,11 @@
           <a:bodyPr wrap="square" lIns="0" tIns="0" rIns="0" bIns="0" rtlCol="0" anchor="ctr"/>
           <a:lstStyle/>
           <a:p>
-            <a:pPr algn="r" indent="0" marL="0">
-              <a:buNone/>
-            </a:pPr>
-            <a:r>
-              <a:rPr lang="en-US" sz="1100" dirty="0">
+            <a:pPr indent="0" marL="0">
+              <a:buNone/>
+            </a:pPr>
+            <a:r>
+              <a:rPr lang="en-US" sz="1050" i="1" dirty="0">
                 <a:solidFill>
                   <a:srgbClr val="5B6B77"/>
                 </a:solidFill>
@@ -4271,233 +4669,48 @@
                 <a:ea typeface="Calibri" pitchFamily="34" charset="-122"/>
                 <a:cs typeface="Calibri" pitchFamily="34" charset="-120"/>
               </a:rPr>
+              <a:t>Llicència Creative Commons BY-NC-SA · Institut Obert de Catalunya, 2011 (materials adaptats i ampliats)</a:t>
+            </a:r>
+            <a:endParaRPr lang="en-US" sz="1050" dirty="0"/>
+          </a:p>
+        </p:txBody>
+      </p:sp>
+      <p:sp>
+        <p:nvSpPr>
+          <p:cNvPr id="17" name="Text 11"/>
+          <p:cNvSpPr txBox="1"/>
+          <p:nvPr/>
+        </p:nvSpPr>
+        <p:spPr>
+          <a:xfrm>
+            <a:off x="11551615" y="6446520"/>
+            <a:ext cx="457200" cy="274320"/>
+          </a:xfrm>
+          <a:prstGeom prst="rect">
+            <a:avLst/>
+          </a:prstGeom>
+          <a:noFill/>
+          <a:ln/>
+        </p:spPr>
+        <p:txBody>
+          <a:bodyPr wrap="square" lIns="0" tIns="0" rIns="0" bIns="0" rtlCol="0" anchor="ctr"/>
+          <a:lstStyle/>
+          <a:p>
+            <a:pPr algn="r" indent="0" marL="0">
+              <a:buNone/>
+            </a:pPr>
+            <a:r>
+              <a:rPr lang="en-US" sz="1100" dirty="0">
+                <a:solidFill>
+                  <a:srgbClr val="5B6B77"/>
+                </a:solidFill>
+                <a:latin typeface="Calibri" pitchFamily="34" charset="0"/>
+                <a:ea typeface="Calibri" pitchFamily="34" charset="-122"/>
+                <a:cs typeface="Calibri" pitchFamily="34" charset="-120"/>
+              </a:rPr>
               <a:t>14</a:t>
             </a:r>
             <a:endParaRPr lang="en-US" sz="1100" dirty="0"/>
-          </a:p>
-        </p:txBody>
-      </p:sp>
-    </p:spTree>
-  </p:cSld>
-  <p:clrMapOvr>
-    <a:masterClrMapping/>
-  </p:clrMapOvr>
-</p:sld>
-</file>
-
-<file path=ppt/slides/slide14.xml><?xml version="1.0" encoding="utf-8"?>
-<p:sld xmlns:a="http://schemas.openxmlformats.org/drawingml/2006/main" xmlns:p="http://schemas.openxmlformats.org/presentationml/2006/main" xmlns:r="http://schemas.openxmlformats.org/officeDocument/2006/relationships">
-  <p:cSld>
-    <p:bg>
-      <p:bgPr>
-        <a:solidFill>
-          <a:srgbClr val="F4F7F9"/>
-        </a:solidFill>
-        <a:effectLst/>
-      </p:bgPr>
-    </p:bg>
-    <p:spTree>
-      <p:nvGrpSpPr>
-        <p:cNvPr id="1" name=""/>
-        <p:cNvGrpSpPr/>
-        <p:nvPr/>
-      </p:nvGrpSpPr>
-      <p:grpSpPr/>
-      <p:sp>
-        <p:nvSpPr>
-          <p:cNvPr id="2" name="TextBox 1"/>
-          <p:cNvSpPr txBox="1"/>
-          <p:nvPr/>
-        </p:nvSpPr>
-        <p:spPr>
-          <a:xfrm>
-            <a:off x="548640" y="411480"/>
-            <a:ext cx="10515600" cy="320040"/>
-          </a:xfrm>
-          <a:prstGeom prst="rect">
-            <a:avLst/>
-          </a:prstGeom>
-          <a:noFill/>
-        </p:spPr>
-        <p:txBody>
-          <a:bodyPr wrap="square">
-            <a:spAutoFit/>
-          </a:bodyPr>
-          <a:lstStyle/>
-          <a:p>
-            <a:pPr algn="l"/>
-            <a:r>
-              <a:rPr sz="1300" b="1" i="0">
-                <a:solidFill>
-                  <a:srgbClr val="F2A541"/>
-                </a:solidFill>
-                <a:latin typeface="Calibri"/>
-              </a:rPr>
-              <a:t>UN CAS REAL</a:t>
-            </a:r>
-          </a:p>
-        </p:txBody>
-      </p:sp>
-      <p:sp>
-        <p:nvSpPr>
-          <p:cNvPr id="3" name="TextBox 2"/>
-          <p:cNvSpPr txBox="1"/>
-          <p:nvPr/>
-        </p:nvSpPr>
-        <p:spPr>
-          <a:xfrm>
-            <a:off x="548640" y="685800"/>
-            <a:ext cx="10972800" cy="822960"/>
-          </a:xfrm>
-          <a:prstGeom prst="rect">
-            <a:avLst/>
-          </a:prstGeom>
-          <a:noFill/>
-        </p:spPr>
-        <p:txBody>
-          <a:bodyPr wrap="square">
-            <a:spAutoFit/>
-          </a:bodyPr>
-          <a:lstStyle/>
-          <a:p>
-            <a:pPr algn="l"/>
-            <a:r>
-              <a:rPr sz="2800" b="1" i="0">
-                <a:solidFill>
-                  <a:srgbClr val="16242E"/>
-                </a:solidFill>
-                <a:latin typeface="Cambria"/>
-              </a:rPr>
-              <a:t>El ransomware, cada cop més present</a:t>
-            </a:r>
-          </a:p>
-        </p:txBody>
-      </p:sp>
-      <p:sp>
-        <p:nvSpPr>
-          <p:cNvPr id="4" name="TextBox 3"/>
-          <p:cNvSpPr txBox="1"/>
-          <p:nvPr/>
-        </p:nvSpPr>
-        <p:spPr>
-          <a:xfrm>
-            <a:off x="548640" y="1417320"/>
-            <a:ext cx="10789920" cy="548640"/>
-          </a:xfrm>
-          <a:prstGeom prst="rect">
-            <a:avLst/>
-          </a:prstGeom>
-          <a:noFill/>
-        </p:spPr>
-        <p:txBody>
-          <a:bodyPr wrap="square">
-            <a:spAutoFit/>
-          </a:bodyPr>
-          <a:lstStyle/>
-          <a:p>
-            <a:pPr algn="l"/>
-            <a:r>
-              <a:rPr sz="1300" b="0" i="0">
-                <a:solidFill>
-                  <a:srgbClr val="5B6B77"/>
-                </a:solidFill>
-                <a:latin typeface="Calibri"/>
-              </a:rPr>
-              <a:t>Titulars recents mostren l'abast real d'aquesta amenaça, també a Catalunya.</a:t>
-            </a:r>
-          </a:p>
-        </p:txBody>
-      </p:sp>
-      <p:pic>
-        <p:nvPicPr>
-          <p:cNvPr id="5" name="Picture 4" descr="ransomware.png"/>
-          <p:cNvPicPr>
-            <a:picLocks noChangeAspect="1"/>
-          </p:cNvPicPr>
-          <p:nvPr/>
-        </p:nvPicPr>
-        <p:blipFill>
-          <a:blip r:embed="rId2"/>
-          <a:stretch>
-            <a:fillRect/>
-          </a:stretch>
-        </p:blipFill>
-        <p:spPr>
-          <a:xfrm>
-            <a:off x="4721390" y="1920240"/>
-            <a:ext cx="2748914" cy="4114800"/>
-          </a:xfrm>
-          <a:prstGeom prst="rect">
-            <a:avLst/>
-          </a:prstGeom>
-        </p:spPr>
-      </p:pic>
-      <p:sp>
-        <p:nvSpPr>
-          <p:cNvPr id="6" name="TextBox 5"/>
-          <p:cNvSpPr txBox="1"/>
-          <p:nvPr/>
-        </p:nvSpPr>
-        <p:spPr>
-          <a:xfrm>
-            <a:off x="548640" y="6172200"/>
-            <a:ext cx="11064240" cy="457200"/>
-          </a:xfrm>
-          <a:prstGeom prst="rect">
-            <a:avLst/>
-          </a:prstGeom>
-          <a:noFill/>
-        </p:spPr>
-        <p:txBody>
-          <a:bodyPr wrap="square">
-            <a:spAutoFit/>
-          </a:bodyPr>
-          <a:lstStyle/>
-          <a:p>
-            <a:pPr algn="ctr"/>
-            <a:r>
-              <a:rPr sz="1200" b="0" i="1">
-                <a:solidFill>
-                  <a:srgbClr val="5B6B77"/>
-                </a:solidFill>
-                <a:latin typeface="Calibri"/>
-              </a:rPr>
-              <a:t>El ransomware xifra les dades de la víctima i en demana un rescat econòmic per desxifrar-les.</a:t>
-            </a:r>
-          </a:p>
-        </p:txBody>
-      </p:sp>
-      <p:sp>
-        <p:nvSpPr>
-          <p:cNvPr id="7" name="TextBox 6"/>
-          <p:cNvSpPr txBox="1"/>
-          <p:nvPr/>
-        </p:nvSpPr>
-        <p:spPr>
-          <a:xfrm>
-            <a:off x="11548872" y="6446520"/>
-            <a:ext cx="365760" cy="274320"/>
-          </a:xfrm>
-          <a:prstGeom prst="rect">
-            <a:avLst/>
-          </a:prstGeom>
-          <a:noFill/>
-        </p:spPr>
-        <p:txBody>
-          <a:bodyPr wrap="none">
-            <a:spAutoFit/>
-          </a:bodyPr>
-          <a:lstStyle/>
-          <a:p>
-            <a:pPr algn="r"/>
-            <a:r>
-              <a:rPr sz="1000">
-                <a:solidFill>
-                  <a:srgbClr val="5B6B77"/>
-                </a:solidFill>
-              </a:rPr>
-              <a:t>4</a:t>
-            </a:r>
           </a:p>
         </p:txBody>
       </p:sp>
@@ -5495,6 +5708,230 @@
 </file>
 
 <file path=ppt/slides/slide4.xml><?xml version="1.0" encoding="utf-8"?>
+<p:sld xmlns:a="http://schemas.openxmlformats.org/drawingml/2006/main" xmlns:p="http://schemas.openxmlformats.org/presentationml/2006/main" xmlns:r="http://schemas.openxmlformats.org/officeDocument/2006/relationships">
+  <p:cSld>
+    <p:bg>
+      <p:bgPr>
+        <a:solidFill>
+          <a:srgbClr val="F4F7F9"/>
+        </a:solidFill>
+        <a:effectLst/>
+      </p:bgPr>
+    </p:bg>
+    <p:spTree>
+      <p:nvGrpSpPr>
+        <p:cNvPr id="1" name=""/>
+        <p:cNvGrpSpPr/>
+        <p:nvPr/>
+      </p:nvGrpSpPr>
+      <p:grpSpPr/>
+      <p:sp>
+        <p:nvSpPr>
+          <p:cNvPr id="2" name="TextBox 1"/>
+          <p:cNvSpPr txBox="1"/>
+          <p:nvPr/>
+        </p:nvSpPr>
+        <p:spPr>
+          <a:xfrm>
+            <a:off x="548640" y="411480"/>
+            <a:ext cx="10515600" cy="320040"/>
+          </a:xfrm>
+          <a:prstGeom prst="rect">
+            <a:avLst/>
+          </a:prstGeom>
+          <a:noFill/>
+        </p:spPr>
+        <p:txBody>
+          <a:bodyPr wrap="square">
+            <a:spAutoFit/>
+          </a:bodyPr>
+          <a:lstStyle/>
+          <a:p>
+            <a:pPr algn="l"/>
+            <a:r>
+              <a:rPr sz="1300" b="1" i="0">
+                <a:solidFill>
+                  <a:srgbClr val="F2A541"/>
+                </a:solidFill>
+                <a:latin typeface="Calibri"/>
+              </a:rPr>
+              <a:t>UN CAS REAL</a:t>
+            </a:r>
+          </a:p>
+        </p:txBody>
+      </p:sp>
+      <p:sp>
+        <p:nvSpPr>
+          <p:cNvPr id="3" name="TextBox 2"/>
+          <p:cNvSpPr txBox="1"/>
+          <p:nvPr/>
+        </p:nvSpPr>
+        <p:spPr>
+          <a:xfrm>
+            <a:off x="548640" y="685800"/>
+            <a:ext cx="10972800" cy="822960"/>
+          </a:xfrm>
+          <a:prstGeom prst="rect">
+            <a:avLst/>
+          </a:prstGeom>
+          <a:noFill/>
+        </p:spPr>
+        <p:txBody>
+          <a:bodyPr wrap="square">
+            <a:spAutoFit/>
+          </a:bodyPr>
+          <a:lstStyle/>
+          <a:p>
+            <a:pPr algn="l"/>
+            <a:r>
+              <a:rPr sz="2800" b="1" i="0">
+                <a:solidFill>
+                  <a:srgbClr val="16242E"/>
+                </a:solidFill>
+                <a:latin typeface="Cambria"/>
+              </a:rPr>
+              <a:t>El ransomware, cada cop més present</a:t>
+            </a:r>
+          </a:p>
+        </p:txBody>
+      </p:sp>
+      <p:sp>
+        <p:nvSpPr>
+          <p:cNvPr id="4" name="TextBox 3"/>
+          <p:cNvSpPr txBox="1"/>
+          <p:nvPr/>
+        </p:nvSpPr>
+        <p:spPr>
+          <a:xfrm>
+            <a:off x="548640" y="1417320"/>
+            <a:ext cx="10789920" cy="548640"/>
+          </a:xfrm>
+          <a:prstGeom prst="rect">
+            <a:avLst/>
+          </a:prstGeom>
+          <a:noFill/>
+        </p:spPr>
+        <p:txBody>
+          <a:bodyPr wrap="square">
+            <a:spAutoFit/>
+          </a:bodyPr>
+          <a:lstStyle/>
+          <a:p>
+            <a:pPr algn="l"/>
+            <a:r>
+              <a:rPr sz="1300" b="0" i="0">
+                <a:solidFill>
+                  <a:srgbClr val="5B6B77"/>
+                </a:solidFill>
+                <a:latin typeface="Calibri"/>
+              </a:rPr>
+              <a:t>Titulars recents mostren l'abast real d'aquesta amenaça, també a Catalunya.</a:t>
+            </a:r>
+          </a:p>
+        </p:txBody>
+      </p:sp>
+      <p:pic>
+        <p:nvPicPr>
+          <p:cNvPr id="5" name="Picture 4" descr="ransomware.png"/>
+          <p:cNvPicPr>
+            <a:picLocks noChangeAspect="1"/>
+          </p:cNvPicPr>
+          <p:nvPr/>
+        </p:nvPicPr>
+        <p:blipFill>
+          <a:blip r:embed="rId2"/>
+          <a:stretch>
+            <a:fillRect/>
+          </a:stretch>
+        </p:blipFill>
+        <p:spPr>
+          <a:xfrm>
+            <a:off x="4721390" y="1920240"/>
+            <a:ext cx="2748914" cy="4114800"/>
+          </a:xfrm>
+          <a:prstGeom prst="rect">
+            <a:avLst/>
+          </a:prstGeom>
+        </p:spPr>
+      </p:pic>
+      <p:sp>
+        <p:nvSpPr>
+          <p:cNvPr id="6" name="TextBox 5"/>
+          <p:cNvSpPr txBox="1"/>
+          <p:nvPr/>
+        </p:nvSpPr>
+        <p:spPr>
+          <a:xfrm>
+            <a:off x="548640" y="6172200"/>
+            <a:ext cx="11064240" cy="457200"/>
+          </a:xfrm>
+          <a:prstGeom prst="rect">
+            <a:avLst/>
+          </a:prstGeom>
+          <a:noFill/>
+        </p:spPr>
+        <p:txBody>
+          <a:bodyPr wrap="square">
+            <a:spAutoFit/>
+          </a:bodyPr>
+          <a:lstStyle/>
+          <a:p>
+            <a:pPr algn="ctr"/>
+            <a:r>
+              <a:rPr sz="1200" b="0" i="1">
+                <a:solidFill>
+                  <a:srgbClr val="5B6B77"/>
+                </a:solidFill>
+                <a:latin typeface="Calibri"/>
+              </a:rPr>
+              <a:t>El ransomware xifra les dades de la víctima i en demana un rescat econòmic per desxifrar-les.</a:t>
+            </a:r>
+          </a:p>
+        </p:txBody>
+      </p:sp>
+      <p:sp>
+        <p:nvSpPr>
+          <p:cNvPr id="7" name="TextBox 6"/>
+          <p:cNvSpPr txBox="1"/>
+          <p:nvPr/>
+        </p:nvSpPr>
+        <p:spPr>
+          <a:xfrm>
+            <a:off x="11548872" y="6446520"/>
+            <a:ext cx="365760" cy="274320"/>
+          </a:xfrm>
+          <a:prstGeom prst="rect">
+            <a:avLst/>
+          </a:prstGeom>
+          <a:noFill/>
+        </p:spPr>
+        <p:txBody>
+          <a:bodyPr wrap="none">
+            <a:spAutoFit/>
+          </a:bodyPr>
+          <a:lstStyle/>
+          <a:p>
+            <a:pPr algn="r"/>
+            <a:r>
+              <a:rPr sz="1000">
+                <a:solidFill>
+                  <a:srgbClr val="5B6B77"/>
+                </a:solidFill>
+              </a:rPr>
+              <a:t>4</a:t>
+            </a:r>
+          </a:p>
+        </p:txBody>
+      </p:sp>
+    </p:spTree>
+  </p:cSld>
+  <p:clrMapOvr>
+    <a:masterClrMapping/>
+  </p:clrMapOvr>
+</p:sld>
+</file>
+
+<file path=ppt/slides/slide5.xml><?xml version="1.0" encoding="utf-8"?>
 <p:sld xmlns:a="http://schemas.openxmlformats.org/drawingml/2006/main" xmlns:r="http://schemas.openxmlformats.org/officeDocument/2006/relationships" xmlns:p="http://schemas.openxmlformats.org/presentationml/2006/main">
   <p:cSld name="Slide 4">
     <p:bg>
@@ -5750,6 +6187,10 @@
           </a:solidFill>
           <a:ln/>
         </p:spPr>
+        <p:txBody>
+          <a:bodyPr/>
+          <a:p/>
+        </p:txBody>
       </p:sp>
       <p:pic>
         <p:nvPicPr>
@@ -5825,7 +6266,7 @@
 </p:sld>
 </file>
 
-<file path=ppt/slides/slide5.xml><?xml version="1.0" encoding="utf-8"?>
+<file path=ppt/slides/slide6.xml><?xml version="1.0" encoding="utf-8"?>
 <p:sld xmlns:a="http://schemas.openxmlformats.org/drawingml/2006/main" xmlns:r="http://schemas.openxmlformats.org/officeDocument/2006/relationships" xmlns:p="http://schemas.openxmlformats.org/presentationml/2006/main">
   <p:cSld name="Slide 5">
     <p:bg>
@@ -5999,6 +6440,10 @@
             </a:outerShdw>
           </a:effectLst>
         </p:spPr>
+        <p:txBody>
+          <a:bodyPr/>
+          <a:p/>
+        </p:txBody>
       </p:sp>
       <p:sp>
         <p:nvSpPr>
@@ -6019,6 +6464,10 @@
           </a:solidFill>
           <a:ln/>
         </p:spPr>
+        <p:txBody>
+          <a:bodyPr/>
+          <a:p/>
+        </p:txBody>
       </p:sp>
       <p:pic>
         <p:nvPicPr>
@@ -6158,6 +6607,10 @@
             </a:outerShdw>
           </a:effectLst>
         </p:spPr>
+        <p:txBody>
+          <a:bodyPr/>
+          <a:p/>
+        </p:txBody>
       </p:sp>
       <p:sp>
         <p:nvSpPr>
@@ -6178,6 +6631,10 @@
           </a:solidFill>
           <a:ln/>
         </p:spPr>
+        <p:txBody>
+          <a:bodyPr/>
+          <a:p/>
+        </p:txBody>
       </p:sp>
       <p:pic>
         <p:nvPicPr>
@@ -6292,7 +6749,7 @@
 </p:sld>
 </file>
 
-<file path=ppt/slides/slide6.xml><?xml version="1.0" encoding="utf-8"?>
+<file path=ppt/slides/slide7.xml><?xml version="1.0" encoding="utf-8"?>
 <p:sld xmlns:a="http://schemas.openxmlformats.org/drawingml/2006/main" xmlns:r="http://schemas.openxmlformats.org/officeDocument/2006/relationships" xmlns:p="http://schemas.openxmlformats.org/presentationml/2006/main">
   <p:cSld name="Slide 6">
     <p:bg>
@@ -6466,6 +6923,10 @@
             </a:outerShdw>
           </a:effectLst>
         </p:spPr>
+        <p:txBody>
+          <a:bodyPr/>
+          <a:p/>
+        </p:txBody>
       </p:sp>
       <p:sp>
         <p:nvSpPr>
@@ -6486,6 +6947,10 @@
           </a:solidFill>
           <a:ln/>
         </p:spPr>
+        <p:txBody>
+          <a:bodyPr/>
+          <a:p/>
+        </p:txBody>
       </p:sp>
       <p:pic>
         <p:nvPicPr>
@@ -6625,6 +7090,10 @@
             </a:outerShdw>
           </a:effectLst>
         </p:spPr>
+        <p:txBody>
+          <a:bodyPr/>
+          <a:p/>
+        </p:txBody>
       </p:sp>
       <p:sp>
         <p:nvSpPr>
@@ -6645,6 +7114,10 @@
           </a:solidFill>
           <a:ln/>
         </p:spPr>
+        <p:txBody>
+          <a:bodyPr/>
+          <a:p/>
+        </p:txBody>
       </p:sp>
       <p:pic>
         <p:nvPicPr>
@@ -6772,6 +7245,10 @@
           </a:solidFill>
           <a:ln/>
         </p:spPr>
+        <p:txBody>
+          <a:bodyPr/>
+          <a:p/>
+        </p:txBody>
       </p:sp>
       <p:pic>
         <p:nvPicPr>
@@ -6847,7 +7324,7 @@
 </p:sld>
 </file>
 
-<file path=ppt/slides/slide7.xml><?xml version="1.0" encoding="utf-8"?>
+<file path=ppt/slides/slide8.xml><?xml version="1.0" encoding="utf-8"?>
 <p:sld xmlns:a="http://schemas.openxmlformats.org/drawingml/2006/main" xmlns:r="http://schemas.openxmlformats.org/officeDocument/2006/relationships" xmlns:p="http://schemas.openxmlformats.org/presentationml/2006/main">
   <p:cSld name="Slide 7">
     <p:bg>
@@ -7079,6 +7556,10 @@
           </a:solidFill>
           <a:ln/>
         </p:spPr>
+        <p:txBody>
+          <a:bodyPr/>
+          <a:p/>
+        </p:txBody>
       </p:sp>
       <p:pic>
         <p:nvPicPr>
@@ -7154,7 +7635,7 @@
 </p:sld>
 </file>
 
-<file path=ppt/slides/slide8.xml><?xml version="1.0" encoding="utf-8"?>
+<file path=ppt/slides/slide9.xml><?xml version="1.0" encoding="utf-8"?>
 <p:sld xmlns:a="http://schemas.openxmlformats.org/drawingml/2006/main" xmlns:r="http://schemas.openxmlformats.org/officeDocument/2006/relationships" xmlns:p="http://schemas.openxmlformats.org/presentationml/2006/main">
   <p:cSld name="Slide 8">
     <p:bg>
@@ -7328,6 +7809,10 @@
             </a:outerShdw>
           </a:effectLst>
         </p:spPr>
+        <p:txBody>
+          <a:bodyPr/>
+          <a:p/>
+        </p:txBody>
       </p:sp>
       <p:sp>
         <p:nvSpPr>
@@ -7348,6 +7833,10 @@
           </a:solidFill>
           <a:ln/>
         </p:spPr>
+        <p:txBody>
+          <a:bodyPr/>
+          <a:p/>
+        </p:txBody>
       </p:sp>
       <p:pic>
         <p:nvPicPr>
@@ -7487,6 +7976,10 @@
             </a:outerShdw>
           </a:effectLst>
         </p:spPr>
+        <p:txBody>
+          <a:bodyPr/>
+          <a:p/>
+        </p:txBody>
       </p:sp>
       <p:sp>
         <p:nvSpPr>
@@ -7507,6 +8000,10 @@
           </a:solidFill>
           <a:ln/>
         </p:spPr>
+        <p:txBody>
+          <a:bodyPr/>
+          <a:p/>
+        </p:txBody>
       </p:sp>
       <p:pic>
         <p:nvPicPr>
@@ -7646,6 +8143,10 @@
             </a:outerShdw>
           </a:effectLst>
         </p:spPr>
+        <p:txBody>
+          <a:bodyPr/>
+          <a:p/>
+        </p:txBody>
       </p:sp>
       <p:sp>
         <p:nvSpPr>
@@ -7666,6 +8167,10 @@
           </a:solidFill>
           <a:ln/>
         </p:spPr>
+        <p:txBody>
+          <a:bodyPr/>
+          <a:p/>
+        </p:txBody>
       </p:sp>
       <p:pic>
         <p:nvPicPr>
@@ -7769,313 +8274,6 @@
               <a:t>Sobreescriure la informació amb dades aleatòries. Funciona en suports magnètics i flaix (SSD, USB, targetes SD) i sí que permet reutilitzar el dispositiu.</a:t>
             </a:r>
             <a:endParaRPr lang="en-US" sz="1250" dirty="0"/>
-          </a:p>
-        </p:txBody>
-      </p:sp>
-    </p:spTree>
-  </p:cSld>
-  <p:clrMapOvr>
-    <a:masterClrMapping/>
-  </p:clrMapOvr>
-</p:sld>
-</file>
-
-<file path=ppt/slides/slide9.xml><?xml version="1.0" encoding="utf-8"?>
-<p:sld xmlns:a="http://schemas.openxmlformats.org/drawingml/2006/main" xmlns:r="http://schemas.openxmlformats.org/officeDocument/2006/relationships" xmlns:p="http://schemas.openxmlformats.org/presentationml/2006/main">
-  <p:cSld name="Slide 9">
-    <p:bg>
-      <p:bgPr>
-        <a:solidFill>
-          <a:srgbClr val="F4F7F9"/>
-        </a:solidFill>
-      </p:bgPr>
-    </p:bg>
-    <p:spTree>
-      <p:nvGrpSpPr>
-        <p:cNvPr id="1" name=""/>
-        <p:cNvGrpSpPr/>
-        <p:nvPr/>
-      </p:nvGrpSpPr>
-      <p:grpSpPr>
-        <a:xfrm>
-          <a:off x="0" y="0"/>
-          <a:ext cx="0" cy="0"/>
-          <a:chOff x="0" y="0"/>
-          <a:chExt cx="0" cy="0"/>
-        </a:xfrm>
-      </p:grpSpPr>
-      <p:sp>
-        <p:nvSpPr>
-          <p:cNvPr id="2" name="Text 0"/>
-          <p:cNvSpPr txBox="1"/>
-          <p:nvPr/>
-        </p:nvSpPr>
-        <p:spPr>
-          <a:xfrm>
-            <a:off x="548640" y="457200"/>
-            <a:ext cx="9144000" cy="365760"/>
-          </a:xfrm>
-          <a:prstGeom prst="rect">
-            <a:avLst/>
-          </a:prstGeom>
-          <a:noFill/>
-          <a:ln/>
-        </p:spPr>
-        <p:txBody>
-          <a:bodyPr wrap="square" lIns="0" tIns="0" rIns="0" bIns="0" rtlCol="0" anchor="ctr"/>
-          <a:lstStyle/>
-          <a:p>
-            <a:pPr indent="0" marL="0">
-              <a:buNone/>
-            </a:pPr>
-            <a:r>
-              <a:rPr lang="en-US" sz="1300" b="1" spc="200" kern="0" dirty="0">
-                <a:solidFill>
-                  <a:srgbClr val="F2A541"/>
-                </a:solidFill>
-                <a:latin typeface="Calibri" pitchFamily="34" charset="0"/>
-                <a:ea typeface="Calibri" pitchFamily="34" charset="-122"/>
-                <a:cs typeface="Calibri" pitchFamily="34" charset="-120"/>
-              </a:rPr>
-              <a:t>ESTÀNDARD DE REFERÈNCIA</a:t>
-            </a:r>
-            <a:endParaRPr lang="en-US" sz="1300" dirty="0"/>
-          </a:p>
-        </p:txBody>
-      </p:sp>
-      <p:sp>
-        <p:nvSpPr>
-          <p:cNvPr id="3" name="Text 1"/>
-          <p:cNvSpPr txBox="1"/>
-          <p:nvPr/>
-        </p:nvSpPr>
-        <p:spPr>
-          <a:xfrm>
-            <a:off x="548640" y="822960"/>
-            <a:ext cx="10789920" cy="640080"/>
-          </a:xfrm>
-          <a:prstGeom prst="rect">
-            <a:avLst/>
-          </a:prstGeom>
-          <a:noFill/>
-          <a:ln/>
-        </p:spPr>
-        <p:txBody>
-          <a:bodyPr wrap="square" lIns="0" tIns="0" rIns="0" bIns="0" rtlCol="0" anchor="ctr"/>
-          <a:lstStyle/>
-          <a:p>
-            <a:pPr indent="0" marL="0">
-              <a:buNone/>
-            </a:pPr>
-            <a:r>
-              <a:rPr lang="en-US" sz="2800" b="1" dirty="0">
-                <a:solidFill>
-                  <a:srgbClr val="16242E"/>
-                </a:solidFill>
-                <a:latin typeface="Cambria" pitchFamily="34" charset="0"/>
-                <a:ea typeface="Cambria" pitchFamily="34" charset="-122"/>
-                <a:cs typeface="Cambria" pitchFamily="34" charset="-120"/>
-              </a:rPr>
-              <a:t>DoD 5220.22-M</a:t>
-            </a:r>
-            <a:endParaRPr lang="en-US" sz="2800" dirty="0"/>
-          </a:p>
-        </p:txBody>
-      </p:sp>
-      <p:sp>
-        <p:nvSpPr>
-          <p:cNvPr id="4" name="Text 2"/>
-          <p:cNvSpPr txBox="1"/>
-          <p:nvPr/>
-        </p:nvSpPr>
-        <p:spPr>
-          <a:xfrm>
-            <a:off x="11551615" y="6446520"/>
-            <a:ext cx="457200" cy="274320"/>
-          </a:xfrm>
-          <a:prstGeom prst="rect">
-            <a:avLst/>
-          </a:prstGeom>
-          <a:noFill/>
-          <a:ln/>
-        </p:spPr>
-        <p:txBody>
-          <a:bodyPr wrap="square" lIns="0" tIns="0" rIns="0" bIns="0" rtlCol="0" anchor="ctr"/>
-          <a:lstStyle/>
-          <a:p>
-            <a:pPr algn="r" indent="0" marL="0">
-              <a:buNone/>
-            </a:pPr>
-            <a:r>
-              <a:rPr lang="en-US" sz="1100" dirty="0">
-                <a:solidFill>
-                  <a:srgbClr val="5B6B77"/>
-                </a:solidFill>
-                <a:latin typeface="Calibri" pitchFamily="34" charset="0"/>
-                <a:ea typeface="Calibri" pitchFamily="34" charset="-122"/>
-                <a:cs typeface="Calibri" pitchFamily="34" charset="-120"/>
-              </a:rPr>
-              <a:t>10</a:t>
-            </a:r>
-            <a:endParaRPr lang="en-US" sz="1100" dirty="0"/>
-          </a:p>
-        </p:txBody>
-      </p:sp>
-      <p:sp>
-        <p:nvSpPr>
-          <p:cNvPr id="5" name="Shape 3"/>
-          <p:cNvSpPr/>
-          <p:nvPr/>
-        </p:nvSpPr>
-        <p:spPr>
-          <a:xfrm>
-            <a:off x="914400" y="2103120"/>
-            <a:ext cx="10332720" cy="1645920"/>
-          </a:xfrm>
-          <a:prstGeom prst="roundRect">
-            <a:avLst>
-              <a:gd name="adj" fmla="val 5556"/>
-            </a:avLst>
-          </a:prstGeom>
-          <a:solidFill>
-            <a:srgbClr val="0B1B29"/>
-          </a:solidFill>
-          <a:ln/>
-        </p:spPr>
-      </p:sp>
-      <p:pic>
-        <p:nvPicPr>
-          <p:cNvPr id="6" name="Image 0" descr="/tmp/claude-0/-home-user-SMX-0226-Seguretat-Informatica/cec25c9b-7e93-584a-a64a-196540977a59/scratchpad/build/icons/checkcircle_F2A541.png">    </p:cNvPr>
-          <p:cNvPicPr>
-            <a:picLocks noChangeAspect="1"/>
-          </p:cNvPicPr>
-          <p:nvPr/>
-        </p:nvPicPr>
-        <p:blipFill>
-          <a:blip r:embed="rId1"/>
-          <a:stretch>
-            <a:fillRect/>
-          </a:stretch>
-        </p:blipFill>
-        <p:spPr>
-          <a:xfrm>
-            <a:off x="1188720" y="2697480"/>
-            <a:ext cx="457200" cy="457200"/>
-          </a:xfrm>
-          <a:prstGeom prst="rect">
-            <a:avLst/>
-          </a:prstGeom>
-        </p:spPr>
-      </p:pic>
-      <p:sp>
-        <p:nvSpPr>
-          <p:cNvPr id="7" name="Text 4"/>
-          <p:cNvSpPr txBox="1"/>
-          <p:nvPr/>
-        </p:nvSpPr>
-        <p:spPr>
-          <a:xfrm>
-            <a:off x="1828800" y="2240280"/>
-            <a:ext cx="9144000" cy="1371600"/>
-          </a:xfrm>
-          <a:prstGeom prst="rect">
-            <a:avLst/>
-          </a:prstGeom>
-          <a:noFill/>
-          <a:ln/>
-        </p:spPr>
-        <p:txBody>
-          <a:bodyPr wrap="square" lIns="0" tIns="0" rIns="0" bIns="0" rtlCol="0" anchor="ctr"/>
-          <a:lstStyle/>
-          <a:p>
-            <a:pPr indent="0" marL="0">
-              <a:lnSpc>
-                <a:spcPts val="1800"/>
-              </a:lnSpc>
-              <a:buNone/>
-            </a:pPr>
-            <a:r>
-              <a:rPr lang="en-US" sz="1350" i="1" dirty="0">
-                <a:solidFill>
-                  <a:srgbClr val="FFFFFF"/>
-                </a:solidFill>
-                <a:latin typeface="Calibri" pitchFamily="34" charset="0"/>
-                <a:ea typeface="Calibri" pitchFamily="34" charset="-122"/>
-                <a:cs typeface="Calibri" pitchFamily="34" charset="-120"/>
-              </a:rPr>
-              <a:t>El Departament de Defensa dels Estats Units recomana un procediment de sobrescriptura en 3 passades: 1) sobreescriure una vegada amb zeros; 2) sobreescriure tres vegades amb dades aleatòries; 3) sobreescriure una vegada amb uns. Aquesta és l'estratègia que recomana l'estàndard DoD 5220.22-M.</a:t>
-            </a:r>
-            <a:endParaRPr lang="en-US" sz="1350" dirty="0"/>
-          </a:p>
-        </p:txBody>
-      </p:sp>
-      <p:sp>
-        <p:nvSpPr>
-          <p:cNvPr id="8" name="Text 5"/>
-          <p:cNvSpPr txBox="1"/>
-          <p:nvPr/>
-        </p:nvSpPr>
-        <p:spPr>
-          <a:xfrm>
-            <a:off x="914400" y="4114800"/>
-            <a:ext cx="10332720" cy="1645920"/>
-          </a:xfrm>
-          <a:prstGeom prst="rect">
-            <a:avLst/>
-          </a:prstGeom>
-          <a:noFill/>
-          <a:ln/>
-        </p:spPr>
-        <p:txBody>
-          <a:bodyPr wrap="square" lIns="0" tIns="0" rIns="0" bIns="0" rtlCol="0" anchor="t"/>
-          <a:lstStyle/>
-          <a:p>
-            <a:pPr marL="342900" indent="-342900">
-              <a:lnSpc>
-                <a:spcPts val="2000"/>
-              </a:lnSpc>
-              <a:spcAft>
-                <a:spcPts val="1000"/>
-              </a:spcAft>
-              <a:buSzPct val="100000"/>
-              <a:buChar char="▪"/>
-            </a:pPr>
-            <a:r>
-              <a:rPr lang="en-US" sz="1500" dirty="0">
-                <a:solidFill>
-                  <a:srgbClr val="16242E"/>
-                </a:solidFill>
-                <a:latin typeface="Calibri" pitchFamily="34" charset="0"/>
-                <a:ea typeface="Calibri" pitchFamily="34" charset="-122"/>
-                <a:cs typeface="Calibri" pitchFamily="34" charset="-120"/>
-              </a:rPr>
-              <a:t>Un simple "Esborra" o un format ràpid NO elimina realment les dades: només marca l'espai com a disponible.</a:t>
-            </a:r>
-            <a:endParaRPr lang="en-US" sz="1500" dirty="0"/>
-          </a:p>
-          <a:p>
-            <a:pPr marL="342900" indent="-342900">
-              <a:lnSpc>
-                <a:spcPts val="2000"/>
-              </a:lnSpc>
-              <a:spcAft>
-                <a:spcPts val="1000"/>
-              </a:spcAft>
-              <a:buSzPct val="100000"/>
-              <a:buChar char="▪"/>
-            </a:pPr>
-            <a:r>
-              <a:rPr lang="en-US" sz="1500" dirty="0">
-                <a:solidFill>
-                  <a:srgbClr val="16242E"/>
-                </a:solidFill>
-                <a:latin typeface="Calibri" pitchFamily="34" charset="0"/>
-                <a:ea typeface="Calibri" pitchFamily="34" charset="-122"/>
-                <a:cs typeface="Calibri" pitchFamily="34" charset="-120"/>
-              </a:rPr>
-              <a:t>La sobrescriptura no es pot aplicar a dispositius d'un sol ús, com un DVD gravat: en aquest cas només queda la destrucció física.</a:t>
-            </a:r>
-            <a:endParaRPr lang="en-US" sz="1500" dirty="0"/>
           </a:p>
         </p:txBody>
       </p:sp>

</xml_diff>

<commit_message>
RA2-AA1: corregeix el maquetatge de les diapositives 3, 7 i 11
Diapositiva 3: "Continuïtat de negoci" i "Recuperació de desastres" en
paràgrafs separats amb l'etiqueta en negreta. Diapositives 7 i 11: les
dues caselles superiors s'escurcen perquè no se superposin amb la caixa
inferior. El text no canvia; la resta del .pptx es copia byte a byte.

Co-Authored-By: Claude Opus 5.5 <noreply@anthropic.com>
Claude-Session: https://claude.ai/code/session_01BodJZ9PsepvknsFhsdyYkP
</commit_message>
<xml_diff>
--- a/RA2 - Emmagatzematge i copies de seguretat/AA1 - Protegint les dades/RA2_AA1_Protegint_les_dades.pptx
+++ b/RA2 - Emmagatzematge i copies de seguretat/AA1 - Protegint les dades/RA2_AA1_Protegint_les_dades.pptx
@@ -2703,7 +2703,7 @@
         <p:spPr>
           <a:xfrm>
             <a:off x="655168" y="1737360"/>
-            <a:ext cx="5212080" cy="3931920"/>
+            <a:ext cx="5212080" cy="3017520"/>
           </a:xfrm>
           <a:prstGeom prst="roundRect">
             <a:avLst>
@@ -2828,7 +2828,7 @@
         <p:spPr>
           <a:xfrm>
             <a:off x="1020928" y="3611880"/>
-            <a:ext cx="4480560" cy="1920240"/>
+            <a:ext cx="4480560" cy="1051560"/>
           </a:xfrm>
           <a:prstGeom prst="rect">
             <a:avLst/>
@@ -2870,7 +2870,7 @@
         <p:spPr>
           <a:xfrm>
             <a:off x="6324448" y="1737360"/>
-            <a:ext cx="5212080" cy="3931920"/>
+            <a:ext cx="5212080" cy="3017520"/>
           </a:xfrm>
           <a:prstGeom prst="roundRect">
             <a:avLst>
@@ -2995,7 +2995,7 @@
         <p:spPr>
           <a:xfrm>
             <a:off x="6690208" y="3611880"/>
-            <a:ext cx="4480560" cy="1920240"/>
+            <a:ext cx="4480560" cy="1051560"/>
           </a:xfrm>
           <a:prstGeom prst="rect">
             <a:avLst/>
@@ -5646,7 +5646,7 @@
               <a:buNone/>
             </a:pPr>
             <a:r>
-              <a:rPr lang="en-US" sz="1450" dirty="0">
+              <a:rPr lang="en-US" sz="1450" dirty="0" b="1">
                 <a:solidFill>
                   <a:srgbClr val="CADCE8"/>
                 </a:solidFill>
@@ -5654,7 +5654,52 @@
                 <a:ea typeface="Calibri" pitchFamily="34" charset="-122"/>
                 <a:cs typeface="Calibri" pitchFamily="34" charset="-120"/>
               </a:rPr>
-              <a:t>Continuïtat de negoci: seguir operant sense pèrdua durant l'incident. Recuperació de desastres: recuperar la informació i tornar a l'estat anterior un cop ha passat.</a:t>
+              <a:t>Continuïtat de negoci:</a:t>
+            </a:r>
+            <a:r>
+              <a:rPr lang="en-US" sz="1450" dirty="0">
+                <a:solidFill>
+                  <a:srgbClr val="CADCE8"/>
+                </a:solidFill>
+                <a:latin typeface="Calibri" pitchFamily="34" charset="0"/>
+                <a:ea typeface="Calibri" pitchFamily="34" charset="-122"/>
+                <a:cs typeface="Calibri" pitchFamily="34" charset="-120"/>
+              </a:rPr>
+              <a:t> seguir operant sense pèrdua durant l'incident.</a:t>
+            </a:r>
+            <a:endParaRPr lang="en-US" sz="1450" dirty="0"/>
+          </a:p>
+          <a:p>
+            <a:pPr indent="0" marL="0">
+              <a:lnSpc>
+                <a:spcPts val="2000"/>
+              </a:lnSpc>
+              <a:spcBef>
+                <a:spcPts val="1200"/>
+              </a:spcBef>
+              <a:buNone/>
+            </a:pPr>
+            <a:r>
+              <a:rPr lang="en-US" sz="1450" dirty="0" b="1">
+                <a:solidFill>
+                  <a:srgbClr val="CADCE8"/>
+                </a:solidFill>
+                <a:latin typeface="Calibri" pitchFamily="34" charset="0"/>
+                <a:ea typeface="Calibri" pitchFamily="34" charset="-122"/>
+                <a:cs typeface="Calibri" pitchFamily="34" charset="-120"/>
+              </a:rPr>
+              <a:t>Recuperació de desastres:</a:t>
+            </a:r>
+            <a:r>
+              <a:rPr lang="en-US" sz="1450" dirty="0">
+                <a:solidFill>
+                  <a:srgbClr val="CADCE8"/>
+                </a:solidFill>
+                <a:latin typeface="Calibri" pitchFamily="34" charset="0"/>
+                <a:ea typeface="Calibri" pitchFamily="34" charset="-122"/>
+                <a:cs typeface="Calibri" pitchFamily="34" charset="-120"/>
+              </a:rPr>
+              <a:t> recuperar la informació i tornar a l'estat anterior un cop ha passat.</a:t>
             </a:r>
             <a:endParaRPr lang="en-US" sz="1450" dirty="0"/>
           </a:p>
@@ -6899,7 +6944,7 @@
         <p:spPr>
           <a:xfrm>
             <a:off x="655168" y="1737360"/>
-            <a:ext cx="5212080" cy="3931920"/>
+            <a:ext cx="5212080" cy="3017520"/>
           </a:xfrm>
           <a:prstGeom prst="roundRect">
             <a:avLst>
@@ -7024,7 +7069,7 @@
         <p:spPr>
           <a:xfrm>
             <a:off x="1020928" y="3611880"/>
-            <a:ext cx="4480560" cy="1920240"/>
+            <a:ext cx="4480560" cy="1051560"/>
           </a:xfrm>
           <a:prstGeom prst="rect">
             <a:avLst/>
@@ -7066,7 +7111,7 @@
         <p:spPr>
           <a:xfrm>
             <a:off x="6324448" y="1737360"/>
-            <a:ext cx="5212080" cy="3931920"/>
+            <a:ext cx="5212080" cy="3017520"/>
           </a:xfrm>
           <a:prstGeom prst="roundRect">
             <a:avLst>
@@ -7191,7 +7236,7 @@
         <p:spPr>
           <a:xfrm>
             <a:off x="6690208" y="3611880"/>
-            <a:ext cx="4480560" cy="1920240"/>
+            <a:ext cx="4480560" cy="1051560"/>
           </a:xfrm>
           <a:prstGeom prst="rect">
             <a:avLst/>

</xml_diff>

<commit_message>
RA2-AA1: augmenta la mida de la lletra de les diapositives i n'espaia els elements
Text de contingut a 18 pt com a mínim (títols de casella 22 pt, subtítols
20 pt), interlineat proporcional, caselles i caixes redimensionades segons
el text i més espai entre blocs. El text no canvia i es mantenen les 14
diapositives.

Co-Authored-By: Claude Opus 5.5 <noreply@anthropic.com>
Claude-Session: https://claude.ai/code/session_01BodJZ9PsepvknsFhsdyYkP
</commit_message>
<xml_diff>
--- a/RA2 - Emmagatzematge i copies de seguretat/AA1 - Protegint les dades/RA2_AA1_Protegint_les_dades.pptx
+++ b/RA2 - Emmagatzematge i copies de seguretat/AA1 - Protegint les dades/RA2_AA1_Protegint_les_dades.pptx
@@ -2391,8 +2391,8 @@
         </p:nvSpPr>
         <p:spPr>
           <a:xfrm>
-            <a:off x="914400" y="2103120"/>
-            <a:ext cx="10332720" cy="1645920"/>
+            <a:off x="914400" y="1661160"/>
+            <a:ext cx="10332720" cy="1819656"/>
           </a:xfrm>
           <a:prstGeom prst="roundRect">
             <a:avLst>
@@ -2425,7 +2425,7 @@
         </p:blipFill>
         <p:spPr>
           <a:xfrm>
-            <a:off x="1188720" y="2697480"/>
+            <a:off x="1188720" y="2342388"/>
             <a:ext cx="457200" cy="457200"/>
           </a:xfrm>
           <a:prstGeom prst="rect">
@@ -2441,8 +2441,8 @@
         </p:nvSpPr>
         <p:spPr>
           <a:xfrm>
-            <a:off x="1828800" y="2240280"/>
-            <a:ext cx="9144000" cy="1371600"/>
+            <a:off x="1828800" y="1912620"/>
+            <a:ext cx="9144000" cy="1316736"/>
           </a:xfrm>
           <a:prstGeom prst="rect">
             <a:avLst/>
@@ -2456,12 +2456,12 @@
           <a:p>
             <a:pPr indent="0" marL="0">
               <a:lnSpc>
-                <a:spcPts val="1800"/>
+                <a:spcPts val="2592"/>
               </a:lnSpc>
               <a:buNone/>
             </a:pPr>
             <a:r>
-              <a:rPr lang="en-US" sz="1350" i="1" dirty="0">
+              <a:rPr lang="en-US" sz="1800" i="1" dirty="0">
                 <a:solidFill>
                   <a:srgbClr val="FFFFFF"/>
                 </a:solidFill>
@@ -2471,7 +2471,7 @@
               </a:rPr>
               <a:t>El Departament de Defensa dels Estats Units recomana un procediment de sobrescriptura en 3 passades: 1) sobreescriure una vegada amb zeros; 2) sobreescriure tres vegades amb dades aleatòries; 3) sobreescriure una vegada amb uns. Aquesta és l'estratègia que recomana l'estàndard DoD 5220.22-M.</a:t>
             </a:r>
-            <a:endParaRPr lang="en-US" sz="1350" dirty="0"/>
+            <a:endParaRPr lang="en-US" sz="1800" dirty="0"/>
           </a:p>
         </p:txBody>
       </p:sp>
@@ -2483,8 +2483,8 @@
         </p:nvSpPr>
         <p:spPr>
           <a:xfrm>
-            <a:off x="914400" y="4114800"/>
-            <a:ext cx="10332720" cy="1645920"/>
+            <a:off x="914400" y="3892296"/>
+            <a:ext cx="10332720" cy="1773936"/>
           </a:xfrm>
           <a:prstGeom prst="rect">
             <a:avLst/>
@@ -2498,16 +2498,16 @@
           <a:p>
             <a:pPr marL="342900" indent="-342900">
               <a:lnSpc>
-                <a:spcPts val="2000"/>
+                <a:spcPts val="2592"/>
               </a:lnSpc>
               <a:spcAft>
-                <a:spcPts val="1000"/>
+                <a:spcPts val="1800"/>
               </a:spcAft>
               <a:buSzPct val="100000"/>
               <a:buChar char="▪"/>
             </a:pPr>
             <a:r>
-              <a:rPr lang="en-US" sz="1500" dirty="0">
+              <a:rPr lang="en-US" sz="1800" dirty="0">
                 <a:solidFill>
                   <a:srgbClr val="16242E"/>
                 </a:solidFill>
@@ -2517,21 +2517,21 @@
               </a:rPr>
               <a:t>Un simple "Esborra" o un format ràpid NO elimina realment les dades: només marca l'espai com a disponible.</a:t>
             </a:r>
-            <a:endParaRPr lang="en-US" sz="1500" dirty="0"/>
+            <a:endParaRPr lang="en-US" sz="1800" dirty="0"/>
           </a:p>
           <a:p>
             <a:pPr marL="342900" indent="-342900">
               <a:lnSpc>
-                <a:spcPts val="2000"/>
+                <a:spcPts val="2592"/>
               </a:lnSpc>
               <a:spcAft>
-                <a:spcPts val="1000"/>
+                <a:spcPts val="1800"/>
               </a:spcAft>
               <a:buSzPct val="100000"/>
               <a:buChar char="▪"/>
             </a:pPr>
             <a:r>
-              <a:rPr lang="en-US" sz="1500" dirty="0">
+              <a:rPr lang="en-US" sz="1800" dirty="0">
                 <a:solidFill>
                   <a:srgbClr val="16242E"/>
                 </a:solidFill>
@@ -2541,7 +2541,7 @@
               </a:rPr>
               <a:t>La sobrescriptura no es pot aplicar a dispositius d'un sol ús, com un DVD gravat: en aquest cas només queda la destrucció física.</a:t>
             </a:r>
-            <a:endParaRPr lang="en-US" sz="1500" dirty="0"/>
+            <a:endParaRPr lang="en-US" sz="1800" dirty="0"/>
           </a:p>
         </p:txBody>
       </p:sp>
@@ -2702,8 +2702,8 @@
         </p:nvSpPr>
         <p:spPr>
           <a:xfrm>
-            <a:off x="655168" y="1737360"/>
-            <a:ext cx="5212080" cy="3017520"/>
+            <a:off x="655168" y="1661160"/>
+            <a:ext cx="5212080" cy="3200400"/>
           </a:xfrm>
           <a:prstGeom prst="roundRect">
             <a:avLst>
@@ -2740,8 +2740,8 @@
         </p:nvSpPr>
         <p:spPr>
           <a:xfrm>
-            <a:off x="1020928" y="2103120"/>
-            <a:ext cx="822960" cy="822960"/>
+            <a:off x="966064" y="1972056"/>
+            <a:ext cx="731520" cy="731520"/>
           </a:xfrm>
           <a:prstGeom prst="ellipse">
             <a:avLst/>
@@ -2772,7 +2772,7 @@
         </p:blipFill>
         <p:spPr>
           <a:xfrm>
-            <a:off x="1231240" y="2313432"/>
+            <a:off x="1130656" y="2136648"/>
             <a:ext cx="402336" cy="402336"/>
           </a:xfrm>
           <a:prstGeom prst="rect">
@@ -2788,8 +2788,8 @@
         </p:nvSpPr>
         <p:spPr>
           <a:xfrm>
-            <a:off x="1020928" y="3108960"/>
-            <a:ext cx="4480560" cy="457200"/>
+            <a:off x="1926184" y="2170176"/>
+            <a:ext cx="3630168" cy="335280"/>
           </a:xfrm>
           <a:prstGeom prst="rect">
             <a:avLst/>
@@ -2805,7 +2805,7 @@
               <a:buNone/>
             </a:pPr>
             <a:r>
-              <a:rPr lang="en-US" sz="1900" b="1" dirty="0">
+              <a:rPr lang="en-US" sz="2200" b="1" dirty="0">
                 <a:solidFill>
                   <a:srgbClr val="16242E"/>
                 </a:solidFill>
@@ -2815,7 +2815,7 @@
               </a:rPr>
               <a:t>Memòria interna oculta</a:t>
             </a:r>
-            <a:endParaRPr lang="en-US" sz="1900" dirty="0"/>
+            <a:endParaRPr lang="en-US" sz="2200" dirty="0"/>
           </a:p>
         </p:txBody>
       </p:sp>
@@ -2827,8 +2827,8 @@
         </p:nvSpPr>
         <p:spPr>
           <a:xfrm>
-            <a:off x="1020928" y="3611880"/>
-            <a:ext cx="4480560" cy="1051560"/>
+            <a:off x="966064" y="2996184"/>
+            <a:ext cx="4590288" cy="1554480"/>
           </a:xfrm>
           <a:prstGeom prst="rect">
             <a:avLst/>
@@ -2842,12 +2842,12 @@
           <a:p>
             <a:pPr indent="0" marL="0">
               <a:lnSpc>
-                <a:spcPts val="1700"/>
+                <a:spcPts val="2448"/>
               </a:lnSpc>
               <a:buNone/>
             </a:pPr>
             <a:r>
-              <a:rPr lang="en-US" sz="1350" dirty="0">
+              <a:rPr lang="en-US" sz="1800" dirty="0">
                 <a:solidFill>
                   <a:srgbClr val="5B6B77"/>
                 </a:solidFill>
@@ -2857,7 +2857,7 @@
               </a:rPr>
               <a:t>Moltes impressores i fotocopiadores digitals tenen un disc dur intern on queden emmagatzemades còpies dels documents que s'han imprès, escanejat o fotocopiat, sovint durant mesos o anys.</a:t>
             </a:r>
-            <a:endParaRPr lang="en-US" sz="1350" dirty="0"/>
+            <a:endParaRPr lang="en-US" sz="1800" dirty="0"/>
           </a:p>
         </p:txBody>
       </p:sp>
@@ -2869,8 +2869,8 @@
         </p:nvSpPr>
         <p:spPr>
           <a:xfrm>
-            <a:off x="6324448" y="1737360"/>
-            <a:ext cx="5212080" cy="3017520"/>
+            <a:off x="6324448" y="1661160"/>
+            <a:ext cx="5212080" cy="3200400"/>
           </a:xfrm>
           <a:prstGeom prst="roundRect">
             <a:avLst>
@@ -2907,8 +2907,8 @@
         </p:nvSpPr>
         <p:spPr>
           <a:xfrm>
-            <a:off x="6690208" y="2103120"/>
-            <a:ext cx="822960" cy="822960"/>
+            <a:off x="6635344" y="1972056"/>
+            <a:ext cx="731520" cy="731520"/>
           </a:xfrm>
           <a:prstGeom prst="ellipse">
             <a:avLst/>
@@ -2939,7 +2939,7 @@
         </p:blipFill>
         <p:spPr>
           <a:xfrm>
-            <a:off x="6900520" y="2313432"/>
+            <a:off x="6799935" y="2136648"/>
             <a:ext cx="402336" cy="402336"/>
           </a:xfrm>
           <a:prstGeom prst="rect">
@@ -2955,8 +2955,8 @@
         </p:nvSpPr>
         <p:spPr>
           <a:xfrm>
-            <a:off x="6690208" y="3108960"/>
-            <a:ext cx="4480560" cy="457200"/>
+            <a:off x="7595464" y="2170176"/>
+            <a:ext cx="3630168" cy="335280"/>
           </a:xfrm>
           <a:prstGeom prst="rect">
             <a:avLst/>
@@ -2972,7 +2972,7 @@
               <a:buNone/>
             </a:pPr>
             <a:r>
-              <a:rPr lang="en-US" sz="1900" b="1" dirty="0">
+              <a:rPr lang="en-US" sz="2200" b="1" dirty="0">
                 <a:solidFill>
                   <a:srgbClr val="16242E"/>
                 </a:solidFill>
@@ -2982,7 +2982,7 @@
               </a:rPr>
               <a:t>Un cas real i documentat</a:t>
             </a:r>
-            <a:endParaRPr lang="en-US" sz="1900" dirty="0"/>
+            <a:endParaRPr lang="en-US" sz="2200" dirty="0"/>
           </a:p>
         </p:txBody>
       </p:sp>
@@ -2994,8 +2994,8 @@
         </p:nvSpPr>
         <p:spPr>
           <a:xfrm>
-            <a:off x="6690208" y="3611880"/>
-            <a:ext cx="4480560" cy="1051560"/>
+            <a:off x="6635344" y="2996184"/>
+            <a:ext cx="4590288" cy="1554480"/>
           </a:xfrm>
           <a:prstGeom prst="rect">
             <a:avLst/>
@@ -3009,12 +3009,12 @@
           <a:p>
             <a:pPr indent="0" marL="0">
               <a:lnSpc>
-                <a:spcPts val="1700"/>
+                <a:spcPts val="2448"/>
               </a:lnSpc>
               <a:buNone/>
             </a:pPr>
             <a:r>
-              <a:rPr lang="en-US" sz="1350" dirty="0">
+              <a:rPr lang="en-US" sz="1800" dirty="0">
                 <a:solidFill>
                   <a:srgbClr val="5B6B77"/>
                 </a:solidFill>
@@ -3025,7 +3025,7 @@
               <a:t>El reportatge </a:t>
             </a:r>
             <a:r>
-              <a:rPr lang="en-US" sz="1350" dirty="0">
+              <a:rPr lang="en-US" sz="1800" dirty="0">
                 <a:solidFill>
                   <a:srgbClr val="5B6B77"/>
                 </a:solidFill>
@@ -3037,7 +3037,7 @@
               <a:t>"Copy Machines, a Security Risk?"</a:t>
             </a:r>
             <a:r>
-              <a:rPr lang="en-US" sz="1350" dirty="0">
+              <a:rPr lang="en-US" sz="1800" dirty="0">
                 <a:solidFill>
                   <a:srgbClr val="5B6B77"/>
                 </a:solidFill>
@@ -3047,7 +3047,7 @@
               </a:rPr>
               <a:t> (CBS News) va destapar que fotocopiadores donades de baixa o revenudes conservaven milers de documents confidencials sense que ningú ho sabés.</a:t>
             </a:r>
-            <a:endParaRPr lang="en-US" sz="1350" dirty="0"/>
+            <a:endParaRPr lang="en-US" sz="1800" dirty="0"/>
           </a:p>
         </p:txBody>
       </p:sp>
@@ -3059,8 +3059,8 @@
         </p:nvSpPr>
         <p:spPr>
           <a:xfrm>
-            <a:off x="640080" y="5029200"/>
-            <a:ext cx="10789920" cy="777240"/>
+            <a:off x="640080" y="5163312"/>
+            <a:ext cx="10789920" cy="1161288"/>
           </a:xfrm>
           <a:prstGeom prst="roundRect">
             <a:avLst>
@@ -3093,7 +3093,7 @@
         </p:blipFill>
         <p:spPr>
           <a:xfrm>
-            <a:off x="914400" y="5189220"/>
+            <a:off x="914400" y="5515356"/>
             <a:ext cx="457200" cy="457200"/>
           </a:xfrm>
           <a:prstGeom prst="rect">
@@ -3109,8 +3109,8 @@
         </p:nvSpPr>
         <p:spPr>
           <a:xfrm>
-            <a:off x="1554480" y="5166360"/>
-            <a:ext cx="9601200" cy="502920"/>
+            <a:off x="1554480" y="5414772"/>
+            <a:ext cx="9601200" cy="658368"/>
           </a:xfrm>
           <a:prstGeom prst="rect">
             <a:avLst/>
@@ -3124,12 +3124,12 @@
           <a:p>
             <a:pPr indent="0" marL="0">
               <a:lnSpc>
-                <a:spcPts val="1800"/>
+                <a:spcPts val="2592"/>
               </a:lnSpc>
               <a:buNone/>
             </a:pPr>
             <a:r>
-              <a:rPr lang="en-US" sz="1350" i="1" dirty="0">
+              <a:rPr lang="en-US" sz="1800" i="1" dirty="0">
                 <a:solidFill>
                   <a:srgbClr val="FFFFFF"/>
                 </a:solidFill>
@@ -3139,7 +3139,7 @@
               </a:rPr>
               <a:t>Conclusió: a l'hora de donar de baixa equipament, cal pensar més enllà dels ordinadors: qualsevol dispositiu amb memòria interna és un risc potencial de fuita de dades.</a:t>
             </a:r>
-            <a:endParaRPr lang="en-US" sz="1350" dirty="0"/>
+            <a:endParaRPr lang="en-US" sz="1800" dirty="0"/>
           </a:p>
         </p:txBody>
       </p:sp>
@@ -3300,8 +3300,8 @@
         </p:nvSpPr>
         <p:spPr>
           <a:xfrm>
-            <a:off x="632308" y="1737360"/>
-            <a:ext cx="3429000" cy="3840480"/>
+            <a:off x="632308" y="1661160"/>
+            <a:ext cx="3429000" cy="4115816"/>
           </a:xfrm>
           <a:prstGeom prst="roundRect">
             <a:avLst>
@@ -3338,7 +3338,7 @@
         </p:nvSpPr>
         <p:spPr>
           <a:xfrm>
-            <a:off x="952348" y="2057400"/>
+            <a:off x="1016355" y="2045208"/>
             <a:ext cx="731520" cy="731520"/>
           </a:xfrm>
           <a:prstGeom prst="ellipse">
@@ -3370,7 +3370,7 @@
         </p:blipFill>
         <p:spPr>
           <a:xfrm>
-            <a:off x="1135228" y="2240280"/>
+            <a:off x="1199235" y="2228088"/>
             <a:ext cx="365760" cy="365760"/>
           </a:xfrm>
           <a:prstGeom prst="rect">
@@ -3386,8 +3386,8 @@
         </p:nvSpPr>
         <p:spPr>
           <a:xfrm>
-            <a:off x="906628" y="2971800"/>
-            <a:ext cx="2880360" cy="731520"/>
+            <a:off x="1016355" y="3005328"/>
+            <a:ext cx="2660904" cy="670560"/>
           </a:xfrm>
           <a:prstGeom prst="rect">
             <a:avLst/>
@@ -3403,7 +3403,7 @@
               <a:buNone/>
             </a:pPr>
             <a:r>
-              <a:rPr lang="en-US" sz="1700" b="1" dirty="0">
+              <a:rPr lang="en-US" sz="2200" b="1" dirty="0">
                 <a:solidFill>
                   <a:srgbClr val="16242E"/>
                 </a:solidFill>
@@ -3413,7 +3413,7 @@
               </a:rPr>
               <a:t>Continuïtat vs. desastres</a:t>
             </a:r>
-            <a:endParaRPr lang="en-US" sz="1700" dirty="0"/>
+            <a:endParaRPr lang="en-US" sz="2200" dirty="0"/>
           </a:p>
         </p:txBody>
       </p:sp>
@@ -3425,8 +3425,8 @@
         </p:nvSpPr>
         <p:spPr>
           <a:xfrm>
-            <a:off x="906628" y="3611880"/>
-            <a:ext cx="2880360" cy="1828800"/>
+            <a:off x="1016355" y="3813048"/>
+            <a:ext cx="2660904" cy="1579880"/>
           </a:xfrm>
           <a:prstGeom prst="rect">
             <a:avLst/>
@@ -3440,12 +3440,12 @@
           <a:p>
             <a:pPr indent="0" marL="0">
               <a:lnSpc>
-                <a:spcPts val="1600"/>
+                <a:spcPts val="2488"/>
               </a:lnSpc>
               <a:buNone/>
             </a:pPr>
             <a:r>
-              <a:rPr lang="en-US" sz="1250" dirty="0">
+              <a:rPr lang="en-US" sz="1800" dirty="0">
                 <a:solidFill>
                   <a:srgbClr val="5B6B77"/>
                 </a:solidFill>
@@ -3455,7 +3455,7 @@
               </a:rPr>
               <a:t>Seguir operant durant l'incident, o recuperar-se després: dues estratègies complementàries, no excloents.</a:t>
             </a:r>
-            <a:endParaRPr lang="en-US" sz="1250" dirty="0"/>
+            <a:endParaRPr lang="en-US" sz="1800" dirty="0"/>
           </a:p>
         </p:txBody>
       </p:sp>
@@ -3467,8 +3467,8 @@
         </p:nvSpPr>
         <p:spPr>
           <a:xfrm>
-            <a:off x="4381348" y="1737360"/>
-            <a:ext cx="3429000" cy="3840480"/>
+            <a:off x="4381348" y="1661160"/>
+            <a:ext cx="3429000" cy="4115816"/>
           </a:xfrm>
           <a:prstGeom prst="roundRect">
             <a:avLst>
@@ -3505,7 +3505,7 @@
         </p:nvSpPr>
         <p:spPr>
           <a:xfrm>
-            <a:off x="4701388" y="2057400"/>
+            <a:off x="4765396" y="2045208"/>
             <a:ext cx="731520" cy="731520"/>
           </a:xfrm>
           <a:prstGeom prst="ellipse">
@@ -3537,7 +3537,7 @@
         </p:blipFill>
         <p:spPr>
           <a:xfrm>
-            <a:off x="4884268" y="2240280"/>
+            <a:off x="4948276" y="2228088"/>
             <a:ext cx="365760" cy="365760"/>
           </a:xfrm>
           <a:prstGeom prst="rect">
@@ -3553,8 +3553,8 @@
         </p:nvSpPr>
         <p:spPr>
           <a:xfrm>
-            <a:off x="4655668" y="2971800"/>
-            <a:ext cx="2880360" cy="731520"/>
+            <a:off x="4765396" y="3005328"/>
+            <a:ext cx="2660904" cy="670560"/>
           </a:xfrm>
           <a:prstGeom prst="rect">
             <a:avLst/>
@@ -3570,7 +3570,7 @@
               <a:buNone/>
             </a:pPr>
             <a:r>
-              <a:rPr lang="en-US" sz="1700" b="1" dirty="0">
+              <a:rPr lang="en-US" sz="2200" b="1" dirty="0">
                 <a:solidFill>
                   <a:srgbClr val="16242E"/>
                 </a:solidFill>
@@ -3580,7 +3580,7 @@
               </a:rPr>
               <a:t>La redundància és la base</a:t>
             </a:r>
-            <a:endParaRPr lang="en-US" sz="1700" dirty="0"/>
+            <a:endParaRPr lang="en-US" sz="2200" dirty="0"/>
           </a:p>
         </p:txBody>
       </p:sp>
@@ -3592,8 +3592,8 @@
         </p:nvSpPr>
         <p:spPr>
           <a:xfrm>
-            <a:off x="4655668" y="3611880"/>
-            <a:ext cx="2880360" cy="1828800"/>
+            <a:off x="4765396" y="3813048"/>
+            <a:ext cx="2660904" cy="1579880"/>
           </a:xfrm>
           <a:prstGeom prst="rect">
             <a:avLst/>
@@ -3607,12 +3607,12 @@
           <a:p>
             <a:pPr indent="0" marL="0">
               <a:lnSpc>
-                <a:spcPts val="1600"/>
+                <a:spcPts val="2488"/>
               </a:lnSpc>
               <a:buNone/>
             </a:pPr>
             <a:r>
-              <a:rPr lang="en-US" sz="1250" dirty="0">
+              <a:rPr lang="en-US" sz="1800" dirty="0">
                 <a:solidFill>
                   <a:srgbClr val="5B6B77"/>
                 </a:solidFill>
@@ -3622,7 +3622,7 @@
               </a:rPr>
               <a:t>Sistemes d'emmagatzematge redundants: l'estratègia que sempre s'ha d'aplicar per a l'alta disponibilitat.</a:t>
             </a:r>
-            <a:endParaRPr lang="en-US" sz="1250" dirty="0"/>
+            <a:endParaRPr lang="en-US" sz="1800" dirty="0"/>
           </a:p>
         </p:txBody>
       </p:sp>
@@ -3634,8 +3634,8 @@
         </p:nvSpPr>
         <p:spPr>
           <a:xfrm>
-            <a:off x="8130388" y="1737360"/>
-            <a:ext cx="3429000" cy="3840480"/>
+            <a:off x="8130388" y="1661160"/>
+            <a:ext cx="3429000" cy="4115816"/>
           </a:xfrm>
           <a:prstGeom prst="roundRect">
             <a:avLst>
@@ -3672,7 +3672,7 @@
         </p:nvSpPr>
         <p:spPr>
           <a:xfrm>
-            <a:off x="8450428" y="2057400"/>
+            <a:off x="8514436" y="2045208"/>
             <a:ext cx="731520" cy="731520"/>
           </a:xfrm>
           <a:prstGeom prst="ellipse">
@@ -3704,7 +3704,7 @@
         </p:blipFill>
         <p:spPr>
           <a:xfrm>
-            <a:off x="8633308" y="2240280"/>
+            <a:off x="8697316" y="2228088"/>
             <a:ext cx="365760" cy="365760"/>
           </a:xfrm>
           <a:prstGeom prst="rect">
@@ -3720,8 +3720,8 @@
         </p:nvSpPr>
         <p:spPr>
           <a:xfrm>
-            <a:off x="8404708" y="2971800"/>
-            <a:ext cx="2880360" cy="731520"/>
+            <a:off x="8514436" y="3005328"/>
+            <a:ext cx="2660904" cy="335280"/>
           </a:xfrm>
           <a:prstGeom prst="rect">
             <a:avLst/>
@@ -3737,7 +3737,7 @@
               <a:buNone/>
             </a:pPr>
             <a:r>
-              <a:rPr lang="en-US" sz="1700" b="1" dirty="0">
+              <a:rPr lang="en-US" sz="2200" b="1" dirty="0">
                 <a:solidFill>
                   <a:srgbClr val="16242E"/>
                 </a:solidFill>
@@ -3747,7 +3747,7 @@
               </a:rPr>
               <a:t>Destrucció segura</a:t>
             </a:r>
-            <a:endParaRPr lang="en-US" sz="1700" dirty="0"/>
+            <a:endParaRPr lang="en-US" sz="2200" dirty="0"/>
           </a:p>
         </p:txBody>
       </p:sp>
@@ -3759,8 +3759,8 @@
         </p:nvSpPr>
         <p:spPr>
           <a:xfrm>
-            <a:off x="8404708" y="3611880"/>
-            <a:ext cx="2880360" cy="1828800"/>
+            <a:off x="8514436" y="3477768"/>
+            <a:ext cx="2660904" cy="1579880"/>
           </a:xfrm>
           <a:prstGeom prst="rect">
             <a:avLst/>
@@ -3774,12 +3774,12 @@
           <a:p>
             <a:pPr indent="0" marL="0">
               <a:lnSpc>
-                <a:spcPts val="1600"/>
+                <a:spcPts val="2488"/>
               </a:lnSpc>
               <a:buNone/>
             </a:pPr>
             <a:r>
-              <a:rPr lang="en-US" sz="1250" dirty="0">
+              <a:rPr lang="en-US" sz="1800" dirty="0">
                 <a:solidFill>
                   <a:srgbClr val="5B6B77"/>
                 </a:solidFill>
@@ -3789,7 +3789,7 @@
               </a:rPr>
               <a:t>Física, desmagnetització o sobrescriptura (DoD 5220.22-M): cap suport es llença sense abans destruir-ne el contingut.</a:t>
             </a:r>
-            <a:endParaRPr lang="en-US" sz="1250" dirty="0"/>
+            <a:endParaRPr lang="en-US" sz="1800" dirty="0"/>
           </a:p>
         </p:txBody>
       </p:sp>
@@ -3950,12 +3950,12 @@
           <a:p>
             <a:pPr indent="0" marL="0">
               <a:lnSpc>
-                <a:spcPts val="2000"/>
+                <a:spcPts val="2592"/>
               </a:lnSpc>
               <a:buNone/>
             </a:pPr>
             <a:r>
-              <a:rPr lang="en-US" sz="1500" dirty="0">
+              <a:rPr lang="en-US" sz="1800" dirty="0">
                 <a:solidFill>
                   <a:srgbClr val="CADCE8"/>
                 </a:solidFill>
@@ -3965,7 +3965,7 @@
               </a:rPr>
               <a:t>En grups de 3: proposeu un procediment de destrucció/esborrat segur per als discos durs dels ordinadors (que es volen donar a una ONG, per tant s'han de poder reutilitzar) i expliqueu per què cal tenir en compte també la fotocopiadora abans de desfer-se'n.</a:t>
             </a:r>
-            <a:endParaRPr lang="en-US" sz="1500" dirty="0"/>
+            <a:endParaRPr lang="en-US" sz="1800" dirty="0"/>
           </a:p>
         </p:txBody>
       </p:sp>
@@ -3994,7 +3994,7 @@
               <a:buNone/>
             </a:pPr>
             <a:r>
-              <a:rPr lang="en-US" sz="1300" i="1" dirty="0">
+              <a:rPr lang="en-US" sz="1800" i="1" dirty="0">
                 <a:solidFill>
                   <a:srgbClr val="8FA6B8"/>
                 </a:solidFill>
@@ -4004,7 +4004,7 @@
               </a:rPr>
               <a:t>10 minuts en grup + posada en comú</a:t>
             </a:r>
-            <a:endParaRPr lang="en-US" sz="1300" dirty="0"/>
+            <a:endParaRPr lang="en-US" sz="1800" dirty="0"/>
           </a:p>
         </p:txBody>
       </p:sp>
@@ -4173,7 +4173,7 @@
         </p:blipFill>
         <p:spPr>
           <a:xfrm>
-            <a:off x="640080" y="1874520"/>
+            <a:off x="640080" y="1653540"/>
             <a:ext cx="320040" cy="320040"/>
           </a:xfrm>
           <a:prstGeom prst="rect">
@@ -4189,8 +4189,8 @@
         </p:nvSpPr>
         <p:spPr>
           <a:xfrm>
-            <a:off x="1143000" y="1828800"/>
-            <a:ext cx="10058400" cy="320040"/>
+            <a:off x="1143000" y="1661160"/>
+            <a:ext cx="10058400" cy="304800"/>
           </a:xfrm>
           <a:prstGeom prst="rect">
             <a:avLst/>
@@ -4206,7 +4206,7 @@
               <a:buNone/>
             </a:pPr>
             <a:r>
-              <a:rPr lang="en-US" sz="1500" b="1" dirty="0">
+              <a:rPr lang="en-US" sz="2000" b="1" dirty="0">
                 <a:solidFill>
                   <a:srgbClr val="16242E"/>
                 </a:solidFill>
@@ -4216,7 +4216,7 @@
               </a:rPr>
               <a:t>NF2-AA1: Protegint les dades</a:t>
             </a:r>
-            <a:endParaRPr lang="en-US" sz="1500" dirty="0"/>
+            <a:endParaRPr lang="en-US" sz="2000" dirty="0"/>
           </a:p>
         </p:txBody>
       </p:sp>
@@ -4228,8 +4228,8 @@
         </p:nvSpPr>
         <p:spPr>
           <a:xfrm>
-            <a:off x="1143000" y="2176272"/>
-            <a:ext cx="10058400" cy="548640"/>
+            <a:off x="1143000" y="2039112"/>
+            <a:ext cx="10058400" cy="643890"/>
           </a:xfrm>
           <a:prstGeom prst="rect">
             <a:avLst/>
@@ -4243,12 +4243,12 @@
           <a:p>
             <a:pPr indent="0" marL="0">
               <a:lnSpc>
-                <a:spcPts val="1500"/>
+                <a:spcPts val="2535"/>
               </a:lnSpc>
               <a:buNone/>
             </a:pPr>
             <a:r>
-              <a:rPr lang="en-US" sz="1150" dirty="0">
+              <a:rPr lang="en-US" sz="1800" dirty="0">
                 <a:solidFill>
                   <a:srgbClr val="5B6B77"/>
                 </a:solidFill>
@@ -4259,7 +4259,7 @@
               <a:t>Repositori "Materials" (GitHub, SMX-0226SI) · Carlos Alonso Martínez, Escola Pia de Mataró · Llicència CC-BY-SA-4.0 — </a:t>
             </a:r>
             <a:r>
-              <a:rPr lang="en-US" sz="1150" dirty="0">
+              <a:rPr lang="en-US" sz="1800" dirty="0">
                 <a:solidFill>
                   <a:srgbClr val="5B6B77"/>
                 </a:solidFill>
@@ -4270,7 +4270,7 @@
               </a:rPr>
               <a:t>github.com/SMX-0226SI/Materials/blob/main/NF2/AA1-ProtegintDades.md</a:t>
             </a:r>
-            <a:endParaRPr lang="en-US" sz="1150" dirty="0"/>
+            <a:endParaRPr lang="en-US" sz="1800" dirty="0"/>
           </a:p>
         </p:txBody>
       </p:sp>
@@ -4290,7 +4290,7 @@
         </p:blipFill>
         <p:spPr>
           <a:xfrm>
-            <a:off x="640080" y="2926080"/>
+            <a:off x="640080" y="3059430"/>
             <a:ext cx="320040" cy="320040"/>
           </a:xfrm>
           <a:prstGeom prst="rect">
@@ -4306,8 +4306,8 @@
         </p:nvSpPr>
         <p:spPr>
           <a:xfrm>
-            <a:off x="1143000" y="2880360"/>
-            <a:ext cx="10058400" cy="320040"/>
+            <a:off x="1143000" y="3067050"/>
+            <a:ext cx="10058400" cy="304800"/>
           </a:xfrm>
           <a:prstGeom prst="rect">
             <a:avLst/>
@@ -4323,7 +4323,7 @@
               <a:buNone/>
             </a:pPr>
             <a:r>
-              <a:rPr lang="en-US" sz="1500" b="1" dirty="0">
+              <a:rPr lang="en-US" sz="2000" b="1" dirty="0">
                 <a:solidFill>
                   <a:srgbClr val="16242E"/>
                 </a:solidFill>
@@ -4333,7 +4333,7 @@
               </a:rPr>
               <a:t>La importància d'un pla de recuperació de desastres</a:t>
             </a:r>
-            <a:endParaRPr lang="en-US" sz="1500" dirty="0"/>
+            <a:endParaRPr lang="en-US" sz="2000" dirty="0"/>
           </a:p>
         </p:txBody>
       </p:sp>
@@ -4345,8 +4345,8 @@
         </p:nvSpPr>
         <p:spPr>
           <a:xfrm>
-            <a:off x="1143000" y="3227832"/>
-            <a:ext cx="10058400" cy="548640"/>
+            <a:off x="1143000" y="3445002"/>
+            <a:ext cx="10058400" cy="321945"/>
           </a:xfrm>
           <a:prstGeom prst="rect">
             <a:avLst/>
@@ -4360,12 +4360,12 @@
           <a:p>
             <a:pPr indent="0" marL="0">
               <a:lnSpc>
-                <a:spcPts val="1500"/>
+                <a:spcPts val="2535"/>
               </a:lnSpc>
               <a:buNone/>
             </a:pPr>
             <a:r>
-              <a:rPr lang="en-US" sz="1150" dirty="0">
+              <a:rPr lang="en-US" sz="1800" dirty="0">
                 <a:solidFill>
                   <a:srgbClr val="5B6B77"/>
                 </a:solidFill>
@@ -4376,7 +4376,7 @@
               <a:t>IONOS Digital Guide — </a:t>
             </a:r>
             <a:r>
-              <a:rPr lang="en-US" sz="1150" dirty="0">
+              <a:rPr lang="en-US" sz="1800" dirty="0">
                 <a:solidFill>
                   <a:srgbClr val="5B6B77"/>
                 </a:solidFill>
@@ -4387,7 +4387,7 @@
               </a:rPr>
               <a:t>"La importancia de contar con un disaster recovery plan"</a:t>
             </a:r>
-            <a:endParaRPr lang="en-US" sz="1150" dirty="0"/>
+            <a:endParaRPr lang="en-US" sz="1800" dirty="0"/>
           </a:p>
         </p:txBody>
       </p:sp>
@@ -4407,7 +4407,7 @@
         </p:blipFill>
         <p:spPr>
           <a:xfrm>
-            <a:off x="640080" y="3977640"/>
+            <a:off x="640080" y="4143375"/>
             <a:ext cx="320040" cy="320040"/>
           </a:xfrm>
           <a:prstGeom prst="rect">
@@ -4423,8 +4423,8 @@
         </p:nvSpPr>
         <p:spPr>
           <a:xfrm>
-            <a:off x="1143000" y="3931920"/>
-            <a:ext cx="10058400" cy="320040"/>
+            <a:off x="1143000" y="4150995"/>
+            <a:ext cx="10058400" cy="304800"/>
           </a:xfrm>
           <a:prstGeom prst="rect">
             <a:avLst/>
@@ -4440,7 +4440,7 @@
               <a:buNone/>
             </a:pPr>
             <a:r>
-              <a:rPr lang="en-US" sz="1500" b="1" dirty="0">
+              <a:rPr lang="en-US" sz="2000" b="1" dirty="0">
                 <a:solidFill>
                   <a:srgbClr val="16242E"/>
                 </a:solidFill>
@@ -4450,7 +4450,7 @@
               </a:rPr>
               <a:t>Estudi sobre discos durs de segona mà</a:t>
             </a:r>
-            <a:endParaRPr lang="en-US" sz="1500" dirty="0"/>
+            <a:endParaRPr lang="en-US" sz="2000" dirty="0"/>
           </a:p>
         </p:txBody>
       </p:sp>
@@ -4462,8 +4462,8 @@
         </p:nvSpPr>
         <p:spPr>
           <a:xfrm>
-            <a:off x="1143000" y="4279392"/>
-            <a:ext cx="10058400" cy="548640"/>
+            <a:off x="1143000" y="4528947"/>
+            <a:ext cx="10058400" cy="321945"/>
           </a:xfrm>
           <a:prstGeom prst="rect">
             <a:avLst/>
@@ -4477,12 +4477,12 @@
           <a:p>
             <a:pPr indent="0" marL="0">
               <a:lnSpc>
-                <a:spcPts val="1500"/>
+                <a:spcPts val="2535"/>
               </a:lnSpc>
               <a:buNone/>
             </a:pPr>
             <a:r>
-              <a:rPr lang="en-US" sz="1150" dirty="0">
+              <a:rPr lang="en-US" sz="1800" dirty="0">
                 <a:solidFill>
                   <a:srgbClr val="5B6B77"/>
                 </a:solidFill>
@@ -4493,7 +4493,7 @@
               <a:t>PCMag — </a:t>
             </a:r>
             <a:r>
-              <a:rPr lang="en-US" sz="1150" dirty="0">
+              <a:rPr lang="en-US" sz="1800" dirty="0">
                 <a:solidFill>
                   <a:srgbClr val="5B6B77"/>
                 </a:solidFill>
@@ -4505,7 +4505,7 @@
               <a:t>"Many Used Hard Drives Sold on eBay Still Contain Leftover Data"</a:t>
             </a:r>
             <a:r>
-              <a:rPr lang="en-US" sz="1150" dirty="0">
+              <a:rPr lang="en-US" sz="1800" dirty="0">
                 <a:solidFill>
                   <a:srgbClr val="5B6B77"/>
                 </a:solidFill>
@@ -4515,7 +4515,7 @@
               </a:rPr>
               <a:t> (2019)</a:t>
             </a:r>
-            <a:endParaRPr lang="en-US" sz="1150" dirty="0"/>
+            <a:endParaRPr lang="en-US" sz="1800" dirty="0"/>
           </a:p>
         </p:txBody>
       </p:sp>
@@ -4535,7 +4535,7 @@
         </p:blipFill>
         <p:spPr>
           <a:xfrm>
-            <a:off x="640080" y="5029200"/>
+            <a:off x="640080" y="5227320"/>
             <a:ext cx="320040" cy="320040"/>
           </a:xfrm>
           <a:prstGeom prst="rect">
@@ -4551,8 +4551,8 @@
         </p:nvSpPr>
         <p:spPr>
           <a:xfrm>
-            <a:off x="1143000" y="4983480"/>
-            <a:ext cx="10058400" cy="320040"/>
+            <a:off x="1143000" y="5234940"/>
+            <a:ext cx="10058400" cy="304800"/>
           </a:xfrm>
           <a:prstGeom prst="rect">
             <a:avLst/>
@@ -4568,7 +4568,7 @@
               <a:buNone/>
             </a:pPr>
             <a:r>
-              <a:rPr lang="en-US" sz="1500" b="1" dirty="0">
+              <a:rPr lang="en-US" sz="2000" b="1" dirty="0">
                 <a:solidFill>
                   <a:srgbClr val="16242E"/>
                 </a:solidFill>
@@ -4578,7 +4578,7 @@
               </a:rPr>
               <a:t>Vídeo: el risc de seguretat de les fotocopiadores</a:t>
             </a:r>
-            <a:endParaRPr lang="en-US" sz="1500" dirty="0"/>
+            <a:endParaRPr lang="en-US" sz="2000" dirty="0"/>
           </a:p>
         </p:txBody>
       </p:sp>
@@ -4590,8 +4590,8 @@
         </p:nvSpPr>
         <p:spPr>
           <a:xfrm>
-            <a:off x="1143000" y="5330952"/>
-            <a:ext cx="10058400" cy="548640"/>
+            <a:off x="1143000" y="5612892"/>
+            <a:ext cx="10058400" cy="321945"/>
           </a:xfrm>
           <a:prstGeom prst="rect">
             <a:avLst/>
@@ -4605,12 +4605,12 @@
           <a:p>
             <a:pPr indent="0" marL="0">
               <a:lnSpc>
-                <a:spcPts val="1500"/>
+                <a:spcPts val="2535"/>
               </a:lnSpc>
               <a:buNone/>
             </a:pPr>
             <a:r>
-              <a:rPr lang="en-US" sz="1150" dirty="0">
+              <a:rPr lang="en-US" sz="1800" dirty="0">
                 <a:solidFill>
                   <a:srgbClr val="5B6B77"/>
                 </a:solidFill>
@@ -4622,7 +4622,7 @@
               <a:t>"Copy Machines, a Security Risk?"</a:t>
             </a:r>
             <a:r>
-              <a:rPr lang="en-US" sz="1150" dirty="0">
+              <a:rPr lang="en-US" sz="1800" dirty="0">
                 <a:solidFill>
                   <a:srgbClr val="5B6B77"/>
                 </a:solidFill>
@@ -4632,7 +4632,7 @@
               </a:rPr>
               <a:t> — reportatge disponible a YouTube</a:t>
             </a:r>
-            <a:endParaRPr lang="en-US" sz="1150" dirty="0"/>
+            <a:endParaRPr lang="en-US" sz="1800" dirty="0"/>
           </a:p>
         </p:txBody>
       </p:sp>
@@ -4871,8 +4871,8 @@
         </p:nvSpPr>
         <p:spPr>
           <a:xfrm>
-            <a:off x="632308" y="1737360"/>
-            <a:ext cx="3429000" cy="3840480"/>
+            <a:off x="632308" y="1661160"/>
+            <a:ext cx="3429000" cy="3799839"/>
           </a:xfrm>
           <a:prstGeom prst="roundRect">
             <a:avLst>
@@ -4909,7 +4909,7 @@
         </p:nvSpPr>
         <p:spPr>
           <a:xfrm>
-            <a:off x="952348" y="2057400"/>
+            <a:off x="1016355" y="2045208"/>
             <a:ext cx="731520" cy="731520"/>
           </a:xfrm>
           <a:prstGeom prst="ellipse">
@@ -4941,7 +4941,7 @@
         </p:blipFill>
         <p:spPr>
           <a:xfrm>
-            <a:off x="1135228" y="2240280"/>
+            <a:off x="1199235" y="2228088"/>
             <a:ext cx="365760" cy="365760"/>
           </a:xfrm>
           <a:prstGeom prst="rect">
@@ -4957,8 +4957,8 @@
         </p:nvSpPr>
         <p:spPr>
           <a:xfrm>
-            <a:off x="906628" y="2971800"/>
-            <a:ext cx="2880360" cy="731520"/>
+            <a:off x="1016355" y="3005328"/>
+            <a:ext cx="2660904" cy="670560"/>
           </a:xfrm>
           <a:prstGeom prst="rect">
             <a:avLst/>
@@ -4974,7 +4974,7 @@
               <a:buNone/>
             </a:pPr>
             <a:r>
-              <a:rPr lang="en-US" sz="1700" b="1" dirty="0">
+              <a:rPr lang="en-US" sz="2200" b="1" dirty="0">
                 <a:solidFill>
                   <a:srgbClr val="16242E"/>
                 </a:solidFill>
@@ -4984,7 +4984,7 @@
               </a:rPr>
               <a:t>Continuïtat de negoci</a:t>
             </a:r>
-            <a:endParaRPr lang="en-US" sz="1700" dirty="0"/>
+            <a:endParaRPr lang="en-US" sz="2200" dirty="0"/>
           </a:p>
         </p:txBody>
       </p:sp>
@@ -4996,8 +4996,8 @@
         </p:nvSpPr>
         <p:spPr>
           <a:xfrm>
-            <a:off x="906628" y="3611880"/>
-            <a:ext cx="2880360" cy="1828800"/>
+            <a:off x="1016355" y="3813048"/>
+            <a:ext cx="2660904" cy="1263904"/>
           </a:xfrm>
           <a:prstGeom prst="rect">
             <a:avLst/>
@@ -5011,12 +5011,12 @@
           <a:p>
             <a:pPr indent="0" marL="0">
               <a:lnSpc>
-                <a:spcPts val="1600"/>
+                <a:spcPts val="2488"/>
               </a:lnSpc>
               <a:buNone/>
             </a:pPr>
             <a:r>
-              <a:rPr lang="en-US" sz="1250" dirty="0">
+              <a:rPr lang="en-US" sz="1800" dirty="0">
                 <a:solidFill>
                   <a:srgbClr val="5B6B77"/>
                 </a:solidFill>
@@ -5026,7 +5026,7 @@
               </a:rPr>
               <a:t>Com seguir treballant sense interrupció encara que falli un component, gràcies a la redundància.</a:t>
             </a:r>
-            <a:endParaRPr lang="en-US" sz="1250" dirty="0"/>
+            <a:endParaRPr lang="en-US" sz="1800" dirty="0"/>
           </a:p>
         </p:txBody>
       </p:sp>
@@ -5038,8 +5038,8 @@
         </p:nvSpPr>
         <p:spPr>
           <a:xfrm>
-            <a:off x="4381348" y="1737360"/>
-            <a:ext cx="3429000" cy="3840480"/>
+            <a:off x="4381348" y="1661160"/>
+            <a:ext cx="3429000" cy="3799839"/>
           </a:xfrm>
           <a:prstGeom prst="roundRect">
             <a:avLst>
@@ -5076,7 +5076,7 @@
         </p:nvSpPr>
         <p:spPr>
           <a:xfrm>
-            <a:off x="4701388" y="2057400"/>
+            <a:off x="4765396" y="2045208"/>
             <a:ext cx="731520" cy="731520"/>
           </a:xfrm>
           <a:prstGeom prst="ellipse">
@@ -5108,7 +5108,7 @@
         </p:blipFill>
         <p:spPr>
           <a:xfrm>
-            <a:off x="4884268" y="2240280"/>
+            <a:off x="4948276" y="2228088"/>
             <a:ext cx="365760" cy="365760"/>
           </a:xfrm>
           <a:prstGeom prst="rect">
@@ -5124,8 +5124,8 @@
         </p:nvSpPr>
         <p:spPr>
           <a:xfrm>
-            <a:off x="4655668" y="2971800"/>
-            <a:ext cx="2880360" cy="731520"/>
+            <a:off x="4765396" y="3005328"/>
+            <a:ext cx="2660904" cy="670560"/>
           </a:xfrm>
           <a:prstGeom prst="rect">
             <a:avLst/>
@@ -5141,7 +5141,7 @@
               <a:buNone/>
             </a:pPr>
             <a:r>
-              <a:rPr lang="en-US" sz="1700" b="1" dirty="0">
+              <a:rPr lang="en-US" sz="2200" b="1" dirty="0">
                 <a:solidFill>
                   <a:srgbClr val="16242E"/>
                 </a:solidFill>
@@ -5151,7 +5151,7 @@
               </a:rPr>
               <a:t>Recuperació de desastres</a:t>
             </a:r>
-            <a:endParaRPr lang="en-US" sz="1700" dirty="0"/>
+            <a:endParaRPr lang="en-US" sz="2200" dirty="0"/>
           </a:p>
         </p:txBody>
       </p:sp>
@@ -5163,8 +5163,8 @@
         </p:nvSpPr>
         <p:spPr>
           <a:xfrm>
-            <a:off x="4655668" y="3611880"/>
-            <a:ext cx="2880360" cy="1828800"/>
+            <a:off x="4765396" y="3813048"/>
+            <a:ext cx="2660904" cy="1263904"/>
           </a:xfrm>
           <a:prstGeom prst="rect">
             <a:avLst/>
@@ -5178,12 +5178,12 @@
           <a:p>
             <a:pPr indent="0" marL="0">
               <a:lnSpc>
-                <a:spcPts val="1600"/>
+                <a:spcPts val="2488"/>
               </a:lnSpc>
               <a:buNone/>
             </a:pPr>
             <a:r>
-              <a:rPr lang="en-US" sz="1250" dirty="0">
+              <a:rPr lang="en-US" sz="1800" dirty="0">
                 <a:solidFill>
                   <a:srgbClr val="5B6B77"/>
                 </a:solidFill>
@@ -5193,7 +5193,7 @@
               </a:rPr>
               <a:t>Com tornar a l'estat anterior quan un incident ja ha provocat una pèrdua d'accés o de dades.</a:t>
             </a:r>
-            <a:endParaRPr lang="en-US" sz="1250" dirty="0"/>
+            <a:endParaRPr lang="en-US" sz="1800" dirty="0"/>
           </a:p>
         </p:txBody>
       </p:sp>
@@ -5205,8 +5205,8 @@
         </p:nvSpPr>
         <p:spPr>
           <a:xfrm>
-            <a:off x="8130388" y="1737360"/>
-            <a:ext cx="3429000" cy="3840480"/>
+            <a:off x="8130388" y="1661160"/>
+            <a:ext cx="3429000" cy="3799839"/>
           </a:xfrm>
           <a:prstGeom prst="roundRect">
             <a:avLst>
@@ -5243,7 +5243,7 @@
         </p:nvSpPr>
         <p:spPr>
           <a:xfrm>
-            <a:off x="8450428" y="2057400"/>
+            <a:off x="8514436" y="2045208"/>
             <a:ext cx="731520" cy="731520"/>
           </a:xfrm>
           <a:prstGeom prst="ellipse">
@@ -5275,7 +5275,7 @@
         </p:blipFill>
         <p:spPr>
           <a:xfrm>
-            <a:off x="8633308" y="2240280"/>
+            <a:off x="8697316" y="2228088"/>
             <a:ext cx="365760" cy="365760"/>
           </a:xfrm>
           <a:prstGeom prst="rect">
@@ -5291,8 +5291,8 @@
         </p:nvSpPr>
         <p:spPr>
           <a:xfrm>
-            <a:off x="8404708" y="2971800"/>
-            <a:ext cx="2880360" cy="731520"/>
+            <a:off x="8514436" y="3005328"/>
+            <a:ext cx="2660904" cy="670560"/>
           </a:xfrm>
           <a:prstGeom prst="rect">
             <a:avLst/>
@@ -5308,7 +5308,7 @@
               <a:buNone/>
             </a:pPr>
             <a:r>
-              <a:rPr lang="en-US" sz="1700" b="1" dirty="0">
+              <a:rPr lang="en-US" sz="2200" b="1" dirty="0">
                 <a:solidFill>
                   <a:srgbClr val="16242E"/>
                 </a:solidFill>
@@ -5318,7 +5318,7 @@
               </a:rPr>
               <a:t>Cicle de vida i destrucció</a:t>
             </a:r>
-            <a:endParaRPr lang="en-US" sz="1700" dirty="0"/>
+            <a:endParaRPr lang="en-US" sz="2200" dirty="0"/>
           </a:p>
         </p:txBody>
       </p:sp>
@@ -5330,8 +5330,8 @@
         </p:nvSpPr>
         <p:spPr>
           <a:xfrm>
-            <a:off x="8404708" y="3611880"/>
-            <a:ext cx="2880360" cy="1828800"/>
+            <a:off x="8514436" y="3813048"/>
+            <a:ext cx="2660904" cy="1263904"/>
           </a:xfrm>
           <a:prstGeom prst="rect">
             <a:avLst/>
@@ -5345,12 +5345,12 @@
           <a:p>
             <a:pPr indent="0" marL="0">
               <a:lnSpc>
-                <a:spcPts val="1600"/>
+                <a:spcPts val="2488"/>
               </a:lnSpc>
               <a:buNone/>
             </a:pPr>
             <a:r>
-              <a:rPr lang="en-US" sz="1250" dirty="0">
+              <a:rPr lang="en-US" sz="1800" dirty="0">
                 <a:solidFill>
                   <a:srgbClr val="5B6B77"/>
                 </a:solidFill>
@@ -5360,7 +5360,7 @@
               </a:rPr>
               <a:t>Com donar de baixa un suport d'emmagatzematge sense deixar-hi dades recuperables.</a:t>
             </a:r>
-            <a:endParaRPr lang="en-US" sz="1250" dirty="0"/>
+            <a:endParaRPr lang="en-US" sz="1800" dirty="0"/>
           </a:p>
         </p:txBody>
       </p:sp>
@@ -5523,7 +5523,7 @@
               <a:buNone/>
             </a:pPr>
             <a:r>
-              <a:rPr lang="en-US" sz="1500" b="1" dirty="0">
+              <a:rPr lang="en-US" sz="2000" b="1" dirty="0">
                 <a:solidFill>
                   <a:srgbClr val="F2A541"/>
                 </a:solidFill>
@@ -5533,7 +5533,7 @@
               </a:rPr>
               <a:t>El segrest de dades</a:t>
             </a:r>
-            <a:endParaRPr lang="en-US" sz="1500" dirty="0"/>
+            <a:endParaRPr lang="en-US" sz="2000" dirty="0"/>
           </a:p>
         </p:txBody>
       </p:sp>
@@ -5560,12 +5560,12 @@
           <a:p>
             <a:pPr indent="0" marL="0">
               <a:lnSpc>
-                <a:spcPts val="2000"/>
+                <a:spcPts val="2681"/>
               </a:lnSpc>
               <a:buNone/>
             </a:pPr>
             <a:r>
-              <a:rPr lang="en-US" sz="1450" dirty="0">
+              <a:rPr lang="en-US" sz="1800" dirty="0">
                 <a:solidFill>
                   <a:srgbClr val="CADCE8"/>
                 </a:solidFill>
@@ -5575,7 +5575,7 @@
               </a:rPr>
               <a:t>El ransomware —programari que xifra les teves dades i en demana un rescat per desxifrar-les— s'ha convertit en una de les principals amenaces per a les empreses. Per això protegir les dades no és opcional: és una prioritat estratègica.</a:t>
             </a:r>
-            <a:endParaRPr lang="en-US" sz="1450" dirty="0"/>
+            <a:endParaRPr lang="en-US" sz="1800" dirty="0"/>
           </a:p>
         </p:txBody>
       </p:sp>
@@ -5604,7 +5604,7 @@
               <a:buNone/>
             </a:pPr>
             <a:r>
-              <a:rPr lang="en-US" sz="1500" b="1" dirty="0">
+              <a:rPr lang="en-US" sz="2000" b="1" dirty="0">
                 <a:solidFill>
                   <a:srgbClr val="F2A541"/>
                 </a:solidFill>
@@ -5614,7 +5614,7 @@
               </a:rPr>
               <a:t>Dues estratègies complementàries</a:t>
             </a:r>
-            <a:endParaRPr lang="en-US" sz="1500" dirty="0"/>
+            <a:endParaRPr lang="en-US" sz="2000" dirty="0"/>
           </a:p>
         </p:txBody>
       </p:sp>
@@ -5641,12 +5641,12 @@
           <a:p>
             <a:pPr indent="0" marL="0">
               <a:lnSpc>
-                <a:spcPts val="2000"/>
+                <a:spcPts val="2681"/>
               </a:lnSpc>
               <a:buNone/>
             </a:pPr>
             <a:r>
-              <a:rPr lang="en-US" sz="1450" dirty="0" b="1">
+              <a:rPr lang="en-US" sz="1800" dirty="0" b="1">
                 <a:solidFill>
                   <a:srgbClr val="CADCE8"/>
                 </a:solidFill>
@@ -5657,7 +5657,7 @@
               <a:t>Continuïtat de negoci:</a:t>
             </a:r>
             <a:r>
-              <a:rPr lang="en-US" sz="1450" dirty="0">
+              <a:rPr lang="en-US" sz="1800" dirty="0">
                 <a:solidFill>
                   <a:srgbClr val="CADCE8"/>
                 </a:solidFill>
@@ -5667,20 +5667,20 @@
               </a:rPr>
               <a:t> seguir operant sense pèrdua durant l'incident.</a:t>
             </a:r>
-            <a:endParaRPr lang="en-US" sz="1450" dirty="0"/>
+            <a:endParaRPr lang="en-US" sz="1800" dirty="0"/>
           </a:p>
           <a:p>
             <a:pPr indent="0" marL="0">
               <a:lnSpc>
-                <a:spcPts val="2000"/>
+                <a:spcPts val="2681"/>
               </a:lnSpc>
               <a:spcBef>
-                <a:spcPts val="1200"/>
+                <a:spcPts val="2234"/>
               </a:spcBef>
               <a:buNone/>
             </a:pPr>
             <a:r>
-              <a:rPr lang="en-US" sz="1450" dirty="0" b="1">
+              <a:rPr lang="en-US" sz="1800" dirty="0" b="1">
                 <a:solidFill>
                   <a:srgbClr val="CADCE8"/>
                 </a:solidFill>
@@ -5691,7 +5691,7 @@
               <a:t>Recuperació de desastres:</a:t>
             </a:r>
             <a:r>
-              <a:rPr lang="en-US" sz="1450" dirty="0">
+              <a:rPr lang="en-US" sz="1800" dirty="0">
                 <a:solidFill>
                   <a:srgbClr val="CADCE8"/>
                 </a:solidFill>
@@ -5701,7 +5701,7 @@
               </a:rPr>
               <a:t> recuperar la informació i tornar a l'estat anterior un cop ha passat.</a:t>
             </a:r>
-            <a:endParaRPr lang="en-US" sz="1450" dirty="0"/>
+            <a:endParaRPr lang="en-US" sz="1800" dirty="0"/>
           </a:p>
         </p:txBody>
       </p:sp>
@@ -5848,8 +5848,8 @@
         </p:nvSpPr>
         <p:spPr>
           <a:xfrm>
-            <a:off x="548640" y="1417320"/>
-            <a:ext cx="10789920" cy="548640"/>
+            <a:off x="548640" y="1615440"/>
+            <a:ext cx="10789920" cy="365760"/>
           </a:xfrm>
           <a:prstGeom prst="rect">
             <a:avLst/>
@@ -5864,7 +5864,7 @@
           <a:p>
             <a:pPr algn="l"/>
             <a:r>
-              <a:rPr sz="1300" b="0" i="0">
+              <a:rPr sz="1800" b="0" i="0">
                 <a:solidFill>
                   <a:srgbClr val="5B6B77"/>
                 </a:solidFill>
@@ -5891,8 +5891,8 @@
         </p:blipFill>
         <p:spPr>
           <a:xfrm>
-            <a:off x="4721390" y="1920240"/>
-            <a:ext cx="2748914" cy="4114800"/>
+            <a:off x="5123545" y="2392680"/>
+            <a:ext cx="1944602" cy="2910840"/>
           </a:xfrm>
           <a:prstGeom prst="rect">
             <a:avLst/>
@@ -5907,8 +5907,8 @@
         </p:nvSpPr>
         <p:spPr>
           <a:xfrm>
-            <a:off x="548640" y="6172200"/>
-            <a:ext cx="11064240" cy="457200"/>
+            <a:off x="548640" y="5577840"/>
+            <a:ext cx="11064240" cy="365760"/>
           </a:xfrm>
           <a:prstGeom prst="rect">
             <a:avLst/>
@@ -5923,7 +5923,7 @@
           <a:p>
             <a:pPr algn="ctr"/>
             <a:r>
-              <a:rPr sz="1200" b="0" i="1">
+              <a:rPr sz="1800" b="0" i="1">
                 <a:solidFill>
                   <a:srgbClr val="5B6B77"/>
                 </a:solidFill>
@@ -6125,8 +6125,8 @@
         </p:nvSpPr>
         <p:spPr>
           <a:xfrm>
-            <a:off x="640080" y="1737360"/>
-            <a:ext cx="10789920" cy="3108960"/>
+            <a:off x="640080" y="1661160"/>
+            <a:ext cx="10789920" cy="2255900"/>
           </a:xfrm>
           <a:prstGeom prst="rect">
             <a:avLst/>
@@ -6140,16 +6140,16 @@
           <a:p>
             <a:pPr marL="342900" indent="-342900">
               <a:lnSpc>
-                <a:spcPts val="2000"/>
+                <a:spcPts val="2508"/>
               </a:lnSpc>
               <a:spcAft>
-                <a:spcPts val="1000"/>
+                <a:spcPts val="1741"/>
               </a:spcAft>
               <a:buSzPct val="100000"/>
               <a:buChar char="▪"/>
             </a:pPr>
             <a:r>
-              <a:rPr lang="en-US" sz="1550" dirty="0">
+              <a:rPr lang="en-US" sz="1800" dirty="0">
                 <a:solidFill>
                   <a:srgbClr val="16242E"/>
                 </a:solidFill>
@@ -6159,21 +6159,21 @@
               </a:rPr>
               <a:t>La clau per seguir operant i ser resistents davant d'un incident és l'alta disponibilitat: una infraestructura que garanteix l'accés a les dades malgrat es produeixin incidents.</a:t>
             </a:r>
-            <a:endParaRPr lang="en-US" sz="1550" dirty="0"/>
+            <a:endParaRPr lang="en-US" sz="1800" dirty="0"/>
           </a:p>
           <a:p>
             <a:pPr marL="342900" indent="-342900">
               <a:lnSpc>
-                <a:spcPts val="2000"/>
+                <a:spcPts val="2508"/>
               </a:lnSpc>
               <a:spcAft>
-                <a:spcPts val="1000"/>
+                <a:spcPts val="1741"/>
               </a:spcAft>
               <a:buSzPct val="100000"/>
               <a:buChar char="▪"/>
             </a:pPr>
             <a:r>
-              <a:rPr lang="en-US" sz="1550" dirty="0">
+              <a:rPr lang="en-US" sz="1800" dirty="0">
                 <a:solidFill>
                   <a:srgbClr val="16242E"/>
                 </a:solidFill>
@@ -6183,21 +6183,21 @@
               </a:rPr>
               <a:t>Això vol dir disposar de sistemes tolerants a fallades: sistemes que continuen funcionant encara que un dels seus components falli.</a:t>
             </a:r>
-            <a:endParaRPr lang="en-US" sz="1550" dirty="0"/>
+            <a:endParaRPr lang="en-US" sz="1800" dirty="0"/>
           </a:p>
           <a:p>
             <a:pPr marL="342900" indent="-342900">
               <a:lnSpc>
-                <a:spcPts val="2000"/>
+                <a:spcPts val="2508"/>
               </a:lnSpc>
               <a:spcAft>
-                <a:spcPts val="1000"/>
+                <a:spcPts val="1741"/>
               </a:spcAft>
               <a:buSzPct val="100000"/>
               <a:buChar char="▪"/>
             </a:pPr>
             <a:r>
-              <a:rPr lang="en-US" sz="1550" dirty="0">
+              <a:rPr lang="en-US" sz="1800" dirty="0">
                 <a:solidFill>
                   <a:srgbClr val="16242E"/>
                 </a:solidFill>
@@ -6207,7 +6207,7 @@
               </a:rPr>
               <a:t>Per aconseguir-ho necessitem redundància: duplicació de components crítics.</a:t>
             </a:r>
-            <a:endParaRPr lang="en-US" sz="1550" dirty="0"/>
+            <a:endParaRPr lang="en-US" sz="1800" dirty="0"/>
           </a:p>
         </p:txBody>
       </p:sp>
@@ -6219,8 +6219,8 @@
         </p:nvSpPr>
         <p:spPr>
           <a:xfrm>
-            <a:off x="640080" y="5029200"/>
-            <a:ext cx="10789920" cy="822960"/>
+            <a:off x="640080" y="4328541"/>
+            <a:ext cx="10789920" cy="1161288"/>
           </a:xfrm>
           <a:prstGeom prst="roundRect">
             <a:avLst>
@@ -6253,7 +6253,7 @@
         </p:blipFill>
         <p:spPr>
           <a:xfrm>
-            <a:off x="914400" y="5212080"/>
+            <a:off x="914400" y="4680584"/>
             <a:ext cx="457200" cy="457200"/>
           </a:xfrm>
           <a:prstGeom prst="rect">
@@ -6269,8 +6269,8 @@
         </p:nvSpPr>
         <p:spPr>
           <a:xfrm>
-            <a:off x="1554480" y="5166360"/>
-            <a:ext cx="9601200" cy="548640"/>
+            <a:off x="1554480" y="4580001"/>
+            <a:ext cx="9601200" cy="658368"/>
           </a:xfrm>
           <a:prstGeom prst="rect">
             <a:avLst/>
@@ -6284,12 +6284,12 @@
           <a:p>
             <a:pPr indent="0" marL="0">
               <a:lnSpc>
-                <a:spcPts val="1800"/>
+                <a:spcPts val="2592"/>
               </a:lnSpc>
               <a:buNone/>
             </a:pPr>
             <a:r>
-              <a:rPr lang="en-US" sz="1350" i="1" dirty="0">
+              <a:rPr lang="en-US" sz="1800" i="1" dirty="0">
                 <a:solidFill>
                   <a:srgbClr val="FFFFFF"/>
                 </a:solidFill>
@@ -6299,7 +6299,7 @@
               </a:rPr>
               <a:t>La redundància és cara: cal analitzar quin nivell d'alta disponibilitat necessita realment cada cas concret, no tot ho necessita al mateix nivell.</a:t>
             </a:r>
-            <a:endParaRPr lang="en-US" sz="1350" dirty="0"/>
+            <a:endParaRPr lang="en-US" sz="1800" dirty="0"/>
           </a:p>
         </p:txBody>
       </p:sp>
@@ -6460,8 +6460,8 @@
         </p:nvSpPr>
         <p:spPr>
           <a:xfrm>
-            <a:off x="655168" y="1737360"/>
-            <a:ext cx="5212080" cy="3931920"/>
+            <a:off x="655168" y="1661160"/>
+            <a:ext cx="5212080" cy="3968496"/>
           </a:xfrm>
           <a:prstGeom prst="roundRect">
             <a:avLst>
@@ -6498,8 +6498,8 @@
         </p:nvSpPr>
         <p:spPr>
           <a:xfrm>
-            <a:off x="1020928" y="2103120"/>
-            <a:ext cx="822960" cy="822960"/>
+            <a:off x="1039216" y="2045208"/>
+            <a:ext cx="731520" cy="731520"/>
           </a:xfrm>
           <a:prstGeom prst="ellipse">
             <a:avLst/>
@@ -6530,7 +6530,7 @@
         </p:blipFill>
         <p:spPr>
           <a:xfrm>
-            <a:off x="1231240" y="2313432"/>
+            <a:off x="1203808" y="2209800"/>
             <a:ext cx="402336" cy="402336"/>
           </a:xfrm>
           <a:prstGeom prst="rect">
@@ -6546,8 +6546,8 @@
         </p:nvSpPr>
         <p:spPr>
           <a:xfrm>
-            <a:off x="1020928" y="3108960"/>
-            <a:ext cx="4480560" cy="457200"/>
+            <a:off x="1999336" y="2243328"/>
+            <a:ext cx="3483864" cy="335280"/>
           </a:xfrm>
           <a:prstGeom prst="rect">
             <a:avLst/>
@@ -6563,7 +6563,7 @@
               <a:buNone/>
             </a:pPr>
             <a:r>
-              <a:rPr lang="en-US" sz="1900" b="1" dirty="0">
+              <a:rPr lang="en-US" sz="2200" b="1" dirty="0">
                 <a:solidFill>
                   <a:srgbClr val="16242E"/>
                 </a:solidFill>
@@ -6573,7 +6573,7 @@
               </a:rPr>
               <a:t>Servidors redundants</a:t>
             </a:r>
-            <a:endParaRPr lang="en-US" sz="1900" dirty="0"/>
+            <a:endParaRPr lang="en-US" sz="2200" dirty="0"/>
           </a:p>
         </p:txBody>
       </p:sp>
@@ -6585,8 +6585,8 @@
         </p:nvSpPr>
         <p:spPr>
           <a:xfrm>
-            <a:off x="1020928" y="3611880"/>
-            <a:ext cx="4480560" cy="1920240"/>
+            <a:off x="1039216" y="3069336"/>
+            <a:ext cx="4443984" cy="2176272"/>
           </a:xfrm>
           <a:prstGeom prst="rect">
             <a:avLst/>
@@ -6600,12 +6600,12 @@
           <a:p>
             <a:pPr indent="0" marL="0">
               <a:lnSpc>
-                <a:spcPts val="1700"/>
+                <a:spcPts val="2448"/>
               </a:lnSpc>
               <a:buNone/>
             </a:pPr>
             <a:r>
-              <a:rPr lang="en-US" sz="1350" dirty="0">
+              <a:rPr lang="en-US" sz="1800" dirty="0">
                 <a:solidFill>
                   <a:srgbClr val="5B6B77"/>
                 </a:solidFill>
@@ -6615,7 +6615,7 @@
               </a:rPr>
               <a:t>Tenir més d'un servidor amb la mateixa informació, encara que estiguin a la mateixa ubicació. Es pot implantar a la pròpia organització o amb serveis de núvol, que ofereixen servidors redundants dins el mateix centre de dades o en ubicacions geogràfiques diferents.</a:t>
             </a:r>
-            <a:endParaRPr lang="en-US" sz="1350" dirty="0"/>
+            <a:endParaRPr lang="en-US" sz="1800" dirty="0"/>
           </a:p>
         </p:txBody>
       </p:sp>
@@ -6627,8 +6627,8 @@
         </p:nvSpPr>
         <p:spPr>
           <a:xfrm>
-            <a:off x="6324448" y="1737360"/>
-            <a:ext cx="5212080" cy="3931920"/>
+            <a:off x="6324448" y="1661160"/>
+            <a:ext cx="5212080" cy="3968496"/>
           </a:xfrm>
           <a:prstGeom prst="roundRect">
             <a:avLst>
@@ -6665,8 +6665,8 @@
         </p:nvSpPr>
         <p:spPr>
           <a:xfrm>
-            <a:off x="6690208" y="2103120"/>
-            <a:ext cx="822960" cy="822960"/>
+            <a:off x="6708496" y="2045208"/>
+            <a:ext cx="731520" cy="731520"/>
           </a:xfrm>
           <a:prstGeom prst="ellipse">
             <a:avLst/>
@@ -6697,7 +6697,7 @@
         </p:blipFill>
         <p:spPr>
           <a:xfrm>
-            <a:off x="6900520" y="2313432"/>
+            <a:off x="6873087" y="2209800"/>
             <a:ext cx="402336" cy="402336"/>
           </a:xfrm>
           <a:prstGeom prst="rect">
@@ -6713,8 +6713,8 @@
         </p:nvSpPr>
         <p:spPr>
           <a:xfrm>
-            <a:off x="6690208" y="3108960"/>
-            <a:ext cx="4480560" cy="457200"/>
+            <a:off x="7668616" y="2045208"/>
+            <a:ext cx="3483864" cy="1005839"/>
           </a:xfrm>
           <a:prstGeom prst="rect">
             <a:avLst/>
@@ -6730,7 +6730,7 @@
               <a:buNone/>
             </a:pPr>
             <a:r>
-              <a:rPr lang="en-US" sz="1900" b="1" dirty="0">
+              <a:rPr lang="en-US" sz="2200" b="1" dirty="0">
                 <a:solidFill>
                   <a:srgbClr val="16242E"/>
                 </a:solidFill>
@@ -6740,7 +6740,7 @@
               </a:rPr>
               <a:t>Sistemes d'emmagatzematge redundants</a:t>
             </a:r>
-            <a:endParaRPr lang="en-US" sz="1900" dirty="0"/>
+            <a:endParaRPr lang="en-US" sz="2200" dirty="0"/>
           </a:p>
         </p:txBody>
       </p:sp>
@@ -6752,8 +6752,8 @@
         </p:nvSpPr>
         <p:spPr>
           <a:xfrm>
-            <a:off x="6690208" y="3611880"/>
-            <a:ext cx="4480560" cy="1920240"/>
+            <a:off x="6708496" y="3343656"/>
+            <a:ext cx="4443984" cy="1865376"/>
           </a:xfrm>
           <a:prstGeom prst="rect">
             <a:avLst/>
@@ -6767,12 +6767,12 @@
           <a:p>
             <a:pPr indent="0" marL="0">
               <a:lnSpc>
-                <a:spcPts val="1700"/>
+                <a:spcPts val="2448"/>
               </a:lnSpc>
               <a:buNone/>
             </a:pPr>
             <a:r>
-              <a:rPr lang="en-US" sz="1350" dirty="0">
+              <a:rPr lang="en-US" sz="1800" dirty="0">
                 <a:solidFill>
                   <a:srgbClr val="5B6B77"/>
                 </a:solidFill>
@@ -6782,7 +6782,7 @@
               </a:rPr>
               <a:t>Tenir més d'un sistema d'emmagatzematge amb la mateixa informació. Aquesta és l'estratègia que SEMPRE s'aplica: permet que, davant l'avaria d'un disc o SSD, el sistema continuï funcionant sense pèrdua de dades. En parlarem en detall al proper apartat (RAID).</a:t>
             </a:r>
-            <a:endParaRPr lang="en-US" sz="1350" dirty="0"/>
+            <a:endParaRPr lang="en-US" sz="1800" dirty="0"/>
           </a:p>
         </p:txBody>
       </p:sp>
@@ -6943,8 +6943,8 @@
         </p:nvSpPr>
         <p:spPr>
           <a:xfrm>
-            <a:off x="655168" y="1737360"/>
-            <a:ext cx="5212080" cy="3017520"/>
+            <a:off x="655168" y="1661160"/>
+            <a:ext cx="5212080" cy="3035808"/>
           </a:xfrm>
           <a:prstGeom prst="roundRect">
             <a:avLst>
@@ -6981,8 +6981,8 @@
         </p:nvSpPr>
         <p:spPr>
           <a:xfrm>
-            <a:off x="1020928" y="2103120"/>
-            <a:ext cx="822960" cy="822960"/>
+            <a:off x="1039216" y="2045208"/>
+            <a:ext cx="731520" cy="731520"/>
           </a:xfrm>
           <a:prstGeom prst="ellipse">
             <a:avLst/>
@@ -7013,7 +7013,7 @@
         </p:blipFill>
         <p:spPr>
           <a:xfrm>
-            <a:off x="1231240" y="2313432"/>
+            <a:off x="1203808" y="2209800"/>
             <a:ext cx="402336" cy="402336"/>
           </a:xfrm>
           <a:prstGeom prst="rect">
@@ -7029,8 +7029,8 @@
         </p:nvSpPr>
         <p:spPr>
           <a:xfrm>
-            <a:off x="1020928" y="3108960"/>
-            <a:ext cx="4480560" cy="457200"/>
+            <a:off x="1999336" y="2243328"/>
+            <a:ext cx="3483864" cy="335280"/>
           </a:xfrm>
           <a:prstGeom prst="rect">
             <a:avLst/>
@@ -7046,7 +7046,7 @@
               <a:buNone/>
             </a:pPr>
             <a:r>
-              <a:rPr lang="en-US" sz="1900" b="1" dirty="0">
+              <a:rPr lang="en-US" sz="2200" b="1" dirty="0">
                 <a:solidFill>
                   <a:srgbClr val="16242E"/>
                 </a:solidFill>
@@ -7056,7 +7056,7 @@
               </a:rPr>
               <a:t>Recuperació dels sistemes</a:t>
             </a:r>
-            <a:endParaRPr lang="en-US" sz="1900" dirty="0"/>
+            <a:endParaRPr lang="en-US" sz="2200" dirty="0"/>
           </a:p>
         </p:txBody>
       </p:sp>
@@ -7068,8 +7068,8 @@
         </p:nvSpPr>
         <p:spPr>
           <a:xfrm>
-            <a:off x="1020928" y="3611880"/>
-            <a:ext cx="4480560" cy="1051560"/>
+            <a:off x="1039216" y="3069336"/>
+            <a:ext cx="4443984" cy="1243584"/>
           </a:xfrm>
           <a:prstGeom prst="rect">
             <a:avLst/>
@@ -7083,12 +7083,12 @@
           <a:p>
             <a:pPr indent="0" marL="0">
               <a:lnSpc>
-                <a:spcPts val="1700"/>
+                <a:spcPts val="2448"/>
               </a:lnSpc>
               <a:buNone/>
             </a:pPr>
             <a:r>
-              <a:rPr lang="en-US" sz="1350" dirty="0">
+              <a:rPr lang="en-US" sz="1800" dirty="0">
                 <a:solidFill>
                   <a:srgbClr val="5B6B77"/>
                 </a:solidFill>
@@ -7098,7 +7098,7 @@
               </a:rPr>
               <a:t>Utilitzant imatges de restauració, es pot recuperar el sistema operatiu i les aplicacions en poc temps, sense haver de reinstal·lar-ho tot des de zero.</a:t>
             </a:r>
-            <a:endParaRPr lang="en-US" sz="1350" dirty="0"/>
+            <a:endParaRPr lang="en-US" sz="1800" dirty="0"/>
           </a:p>
         </p:txBody>
       </p:sp>
@@ -7110,8 +7110,8 @@
         </p:nvSpPr>
         <p:spPr>
           <a:xfrm>
-            <a:off x="6324448" y="1737360"/>
-            <a:ext cx="5212080" cy="3017520"/>
+            <a:off x="6324448" y="1661160"/>
+            <a:ext cx="5212080" cy="3035808"/>
           </a:xfrm>
           <a:prstGeom prst="roundRect">
             <a:avLst>
@@ -7148,8 +7148,8 @@
         </p:nvSpPr>
         <p:spPr>
           <a:xfrm>
-            <a:off x="6690208" y="2103120"/>
-            <a:ext cx="822960" cy="822960"/>
+            <a:off x="6708496" y="2045208"/>
+            <a:ext cx="731520" cy="731520"/>
           </a:xfrm>
           <a:prstGeom prst="ellipse">
             <a:avLst/>
@@ -7180,7 +7180,7 @@
         </p:blipFill>
         <p:spPr>
           <a:xfrm>
-            <a:off x="6900520" y="2313432"/>
+            <a:off x="6873087" y="2209800"/>
             <a:ext cx="402336" cy="402336"/>
           </a:xfrm>
           <a:prstGeom prst="rect">
@@ -7196,8 +7196,8 @@
         </p:nvSpPr>
         <p:spPr>
           <a:xfrm>
-            <a:off x="6690208" y="3108960"/>
-            <a:ext cx="4480560" cy="457200"/>
+            <a:off x="7668616" y="2243328"/>
+            <a:ext cx="3483864" cy="335280"/>
           </a:xfrm>
           <a:prstGeom prst="rect">
             <a:avLst/>
@@ -7213,7 +7213,7 @@
               <a:buNone/>
             </a:pPr>
             <a:r>
-              <a:rPr lang="en-US" sz="1900" b="1" dirty="0">
+              <a:rPr lang="en-US" sz="2200" b="1" dirty="0">
                 <a:solidFill>
                   <a:srgbClr val="16242E"/>
                 </a:solidFill>
@@ -7223,7 +7223,7 @@
               </a:rPr>
               <a:t>Recuperació de les dades</a:t>
             </a:r>
-            <a:endParaRPr lang="en-US" sz="1900" dirty="0"/>
+            <a:endParaRPr lang="en-US" sz="2200" dirty="0"/>
           </a:p>
         </p:txBody>
       </p:sp>
@@ -7235,8 +7235,8 @@
         </p:nvSpPr>
         <p:spPr>
           <a:xfrm>
-            <a:off x="6690208" y="3611880"/>
-            <a:ext cx="4480560" cy="1051560"/>
+            <a:off x="6708496" y="3069336"/>
+            <a:ext cx="4443984" cy="1243584"/>
           </a:xfrm>
           <a:prstGeom prst="rect">
             <a:avLst/>
@@ -7250,12 +7250,12 @@
           <a:p>
             <a:pPr indent="0" marL="0">
               <a:lnSpc>
-                <a:spcPts val="1700"/>
+                <a:spcPts val="2448"/>
               </a:lnSpc>
               <a:buNone/>
             </a:pPr>
             <a:r>
-              <a:rPr lang="en-US" sz="1350" dirty="0">
+              <a:rPr lang="en-US" sz="1800" dirty="0">
                 <a:solidFill>
                   <a:srgbClr val="5B6B77"/>
                 </a:solidFill>
@@ -7265,7 +7265,7 @@
               </a:rPr>
               <a:t>Utilitzant còpies de seguretat (backup), es poden recuperar els documents, bases de dades i altra informació generada per l'organització.</a:t>
             </a:r>
-            <a:endParaRPr lang="en-US" sz="1350" dirty="0"/>
+            <a:endParaRPr lang="en-US" sz="1800" dirty="0"/>
           </a:p>
         </p:txBody>
       </p:sp>
@@ -7277,8 +7277,8 @@
         </p:nvSpPr>
         <p:spPr>
           <a:xfrm>
-            <a:off x="640080" y="4937760"/>
-            <a:ext cx="10789920" cy="777240"/>
+            <a:off x="640080" y="5108448"/>
+            <a:ext cx="10789920" cy="1161288"/>
           </a:xfrm>
           <a:prstGeom prst="roundRect">
             <a:avLst>
@@ -7311,7 +7311,7 @@
         </p:blipFill>
         <p:spPr>
           <a:xfrm>
-            <a:off x="914400" y="5097780"/>
+            <a:off x="914400" y="5460492"/>
             <a:ext cx="457200" cy="457200"/>
           </a:xfrm>
           <a:prstGeom prst="rect">
@@ -7327,8 +7327,8 @@
         </p:nvSpPr>
         <p:spPr>
           <a:xfrm>
-            <a:off x="1554480" y="5074920"/>
-            <a:ext cx="9601200" cy="502920"/>
+            <a:off x="1554480" y="5359908"/>
+            <a:ext cx="9601200" cy="658368"/>
           </a:xfrm>
           <a:prstGeom prst="rect">
             <a:avLst/>
@@ -7342,12 +7342,12 @@
           <a:p>
             <a:pPr indent="0" marL="0">
               <a:lnSpc>
-                <a:spcPts val="1800"/>
+                <a:spcPts val="2592"/>
               </a:lnSpc>
               <a:buNone/>
             </a:pPr>
             <a:r>
-              <a:rPr lang="en-US" sz="1350" i="1" dirty="0">
+              <a:rPr lang="en-US" sz="1800" i="1" dirty="0">
                 <a:solidFill>
                   <a:srgbClr val="FFFFFF"/>
                 </a:solidFill>
@@ -7357,7 +7357,7 @@
               </a:rPr>
               <a:t>L'objectiu de la recuperació de desastres és tornar al funcionament normal en el mínim temps possible. Aprofundirem en imatges i còpies de seguretat als propers apartats.</a:t>
             </a:r>
-            <a:endParaRPr lang="en-US" sz="1350" dirty="0"/>
+            <a:endParaRPr lang="en-US" sz="1800" dirty="0"/>
           </a:p>
         </p:txBody>
       </p:sp>
@@ -7518,8 +7518,8 @@
         </p:nvSpPr>
         <p:spPr>
           <a:xfrm>
-            <a:off x="640080" y="1737360"/>
-            <a:ext cx="10789920" cy="2926080"/>
+            <a:off x="640080" y="1661160"/>
+            <a:ext cx="10789920" cy="1716277"/>
           </a:xfrm>
           <a:prstGeom prst="rect">
             <a:avLst/>
@@ -7533,16 +7533,16 @@
           <a:p>
             <a:pPr marL="342900" indent="-342900">
               <a:lnSpc>
-                <a:spcPts val="2000"/>
+                <a:spcPts val="2508"/>
               </a:lnSpc>
               <a:spcAft>
-                <a:spcPts val="1000"/>
+                <a:spcPts val="1741"/>
               </a:spcAft>
               <a:buSzPct val="100000"/>
               <a:buChar char="▪"/>
             </a:pPr>
             <a:r>
-              <a:rPr lang="en-US" sz="1550" dirty="0">
+              <a:rPr lang="en-US" sz="1800" dirty="0">
                 <a:solidFill>
                   <a:srgbClr val="16242E"/>
                 </a:solidFill>
@@ -7552,21 +7552,21 @@
               </a:rPr>
               <a:t>Protegir les dades també implica la seguretat física (evitar accessos no autoritzats als equips) i el xifratge (perquè, si les dades es roben, no es puguin llegir).</a:t>
             </a:r>
-            <a:endParaRPr lang="en-US" sz="1550" dirty="0"/>
+            <a:endParaRPr lang="en-US" sz="1800" dirty="0"/>
           </a:p>
           <a:p>
             <a:pPr marL="342900" indent="-342900">
               <a:lnSpc>
-                <a:spcPts val="2000"/>
+                <a:spcPts val="2508"/>
               </a:lnSpc>
               <a:spcAft>
-                <a:spcPts val="1000"/>
+                <a:spcPts val="1741"/>
               </a:spcAft>
               <a:buSzPct val="100000"/>
               <a:buChar char="▪"/>
             </a:pPr>
             <a:r>
-              <a:rPr lang="en-US" sz="1550" dirty="0">
+              <a:rPr lang="en-US" sz="1800" dirty="0">
                 <a:solidFill>
                   <a:srgbClr val="16242E"/>
                 </a:solidFill>
@@ -7576,7 +7576,7 @@
               </a:rPr>
               <a:t>Però hi ha un aspecte sovint oblidat: gestionar el cicle de vida de les dades — com es creen, s'emmagatzemen, s'utilitzen i, finalment, es destrueixen els suports físics quan arriben al final de la seva vida útil.</a:t>
             </a:r>
-            <a:endParaRPr lang="en-US" sz="1550" dirty="0"/>
+            <a:endParaRPr lang="en-US" sz="1800" dirty="0"/>
           </a:p>
         </p:txBody>
       </p:sp>
@@ -7588,8 +7588,8 @@
         </p:nvSpPr>
         <p:spPr>
           <a:xfrm>
-            <a:off x="640080" y="4846320"/>
-            <a:ext cx="10789920" cy="914400"/>
+            <a:off x="640080" y="3788918"/>
+            <a:ext cx="10789920" cy="1161288"/>
           </a:xfrm>
           <a:prstGeom prst="roundRect">
             <a:avLst>
@@ -7622,7 +7622,7 @@
         </p:blipFill>
         <p:spPr>
           <a:xfrm>
-            <a:off x="914400" y="5074920"/>
+            <a:off x="914400" y="4140962"/>
             <a:ext cx="457200" cy="457200"/>
           </a:xfrm>
           <a:prstGeom prst="rect">
@@ -7638,8 +7638,8 @@
         </p:nvSpPr>
         <p:spPr>
           <a:xfrm>
-            <a:off x="1554480" y="4983480"/>
-            <a:ext cx="9601200" cy="640080"/>
+            <a:off x="1554480" y="4040378"/>
+            <a:ext cx="9601200" cy="658368"/>
           </a:xfrm>
           <a:prstGeom prst="rect">
             <a:avLst/>
@@ -7653,12 +7653,12 @@
           <a:p>
             <a:pPr indent="0" marL="0">
               <a:lnSpc>
-                <a:spcPts val="1800"/>
+                <a:spcPts val="2592"/>
               </a:lnSpc>
               <a:buNone/>
             </a:pPr>
             <a:r>
-              <a:rPr lang="en-US" sz="1350" i="1" dirty="0">
+              <a:rPr lang="en-US" sz="1800" i="1" dirty="0">
                 <a:solidFill>
                   <a:srgbClr val="FFFFFF"/>
                 </a:solidFill>
@@ -7668,7 +7668,7 @@
               </a:rPr>
               <a:t>Un estudi de 2019 va descobrir que 3 de cada 5 discos durs de segona mà venuts a eBay encara contenien dades personals i confidencials dels seus antics propietaris.</a:t>
             </a:r>
-            <a:endParaRPr lang="en-US" sz="1350" dirty="0"/>
+            <a:endParaRPr lang="en-US" sz="1800" dirty="0"/>
           </a:p>
         </p:txBody>
       </p:sp>
@@ -7829,8 +7829,8 @@
         </p:nvSpPr>
         <p:spPr>
           <a:xfrm>
-            <a:off x="632308" y="1737360"/>
-            <a:ext cx="3429000" cy="3840480"/>
+            <a:off x="632308" y="1661160"/>
+            <a:ext cx="3429000" cy="4096511"/>
           </a:xfrm>
           <a:prstGeom prst="roundRect">
             <a:avLst>
@@ -7867,7 +7867,7 @@
         </p:nvSpPr>
         <p:spPr>
           <a:xfrm>
-            <a:off x="952348" y="2057400"/>
+            <a:off x="1016355" y="2045208"/>
             <a:ext cx="731520" cy="731520"/>
           </a:xfrm>
           <a:prstGeom prst="ellipse">
@@ -7899,7 +7899,7 @@
         </p:blipFill>
         <p:spPr>
           <a:xfrm>
-            <a:off x="1135228" y="2240280"/>
+            <a:off x="1199235" y="2228088"/>
             <a:ext cx="365760" cy="365760"/>
           </a:xfrm>
           <a:prstGeom prst="rect">
@@ -7915,8 +7915,8 @@
         </p:nvSpPr>
         <p:spPr>
           <a:xfrm>
-            <a:off x="906628" y="2971800"/>
-            <a:ext cx="2880360" cy="731520"/>
+            <a:off x="1016355" y="3005328"/>
+            <a:ext cx="2660904" cy="335280"/>
           </a:xfrm>
           <a:prstGeom prst="rect">
             <a:avLst/>
@@ -7932,7 +7932,7 @@
               <a:buNone/>
             </a:pPr>
             <a:r>
-              <a:rPr lang="en-US" sz="1700" b="1" dirty="0">
+              <a:rPr lang="en-US" sz="2200" b="1" dirty="0">
                 <a:solidFill>
                   <a:srgbClr val="16242E"/>
                 </a:solidFill>
@@ -7942,7 +7942,7 @@
               </a:rPr>
               <a:t>Destrucció física</a:t>
             </a:r>
-            <a:endParaRPr lang="en-US" sz="1700" dirty="0"/>
+            <a:endParaRPr lang="en-US" sz="2200" dirty="0"/>
           </a:p>
         </p:txBody>
       </p:sp>
@@ -7954,8 +7954,8 @@
         </p:nvSpPr>
         <p:spPr>
           <a:xfrm>
-            <a:off x="906628" y="3611880"/>
-            <a:ext cx="2880360" cy="1828800"/>
+            <a:off x="1016355" y="3477768"/>
+            <a:ext cx="2660904" cy="1895856"/>
           </a:xfrm>
           <a:prstGeom prst="rect">
             <a:avLst/>
@@ -7969,12 +7969,12 @@
           <a:p>
             <a:pPr indent="0" marL="0">
               <a:lnSpc>
-                <a:spcPts val="1600"/>
+                <a:spcPts val="2488"/>
               </a:lnSpc>
               <a:buNone/>
             </a:pPr>
             <a:r>
-              <a:rPr lang="en-US" sz="1250" dirty="0">
+              <a:rPr lang="en-US" sz="1800" dirty="0">
                 <a:solidFill>
                   <a:srgbClr val="5B6B77"/>
                 </a:solidFill>
@@ -7984,7 +7984,7 @@
               </a:rPr>
               <a:t>Destruir el suport físicament (trituradores, perforadores) perquè la informació no es pugui recuperar mai. La més segura, però no permet reutilitzar el dispositiu.</a:t>
             </a:r>
-            <a:endParaRPr lang="en-US" sz="1250" dirty="0"/>
+            <a:endParaRPr lang="en-US" sz="1800" dirty="0"/>
           </a:p>
         </p:txBody>
       </p:sp>
@@ -7996,8 +7996,8 @@
         </p:nvSpPr>
         <p:spPr>
           <a:xfrm>
-            <a:off x="4381348" y="1737360"/>
-            <a:ext cx="3429000" cy="3840480"/>
+            <a:off x="4381348" y="1661160"/>
+            <a:ext cx="3429000" cy="4096511"/>
           </a:xfrm>
           <a:prstGeom prst="roundRect">
             <a:avLst>
@@ -8034,7 +8034,7 @@
         </p:nvSpPr>
         <p:spPr>
           <a:xfrm>
-            <a:off x="4701388" y="2057400"/>
+            <a:off x="4765396" y="2045208"/>
             <a:ext cx="731520" cy="731520"/>
           </a:xfrm>
           <a:prstGeom prst="ellipse">
@@ -8066,7 +8066,7 @@
         </p:blipFill>
         <p:spPr>
           <a:xfrm>
-            <a:off x="4884268" y="2240280"/>
+            <a:off x="4948276" y="2228088"/>
             <a:ext cx="365760" cy="365760"/>
           </a:xfrm>
           <a:prstGeom prst="rect">
@@ -8082,8 +8082,8 @@
         </p:nvSpPr>
         <p:spPr>
           <a:xfrm>
-            <a:off x="4655668" y="2971800"/>
-            <a:ext cx="2880360" cy="731520"/>
+            <a:off x="4765396" y="3005328"/>
+            <a:ext cx="2660904" cy="335280"/>
           </a:xfrm>
           <a:prstGeom prst="rect">
             <a:avLst/>
@@ -8099,7 +8099,7 @@
               <a:buNone/>
             </a:pPr>
             <a:r>
-              <a:rPr lang="en-US" sz="1700" b="1" dirty="0">
+              <a:rPr lang="en-US" sz="2200" b="1" dirty="0">
                 <a:solidFill>
                   <a:srgbClr val="16242E"/>
                 </a:solidFill>
@@ -8109,7 +8109,7 @@
               </a:rPr>
               <a:t>Desmagnetització</a:t>
             </a:r>
-            <a:endParaRPr lang="en-US" sz="1700" dirty="0"/>
+            <a:endParaRPr lang="en-US" sz="2200" dirty="0"/>
           </a:p>
         </p:txBody>
       </p:sp>
@@ -8121,8 +8121,8 @@
         </p:nvSpPr>
         <p:spPr>
           <a:xfrm>
-            <a:off x="4655668" y="3611880"/>
-            <a:ext cx="2880360" cy="1828800"/>
+            <a:off x="4765396" y="3477768"/>
+            <a:ext cx="2660904" cy="1579880"/>
           </a:xfrm>
           <a:prstGeom prst="rect">
             <a:avLst/>
@@ -8136,12 +8136,12 @@
           <a:p>
             <a:pPr indent="0" marL="0">
               <a:lnSpc>
-                <a:spcPts val="1600"/>
+                <a:spcPts val="2488"/>
               </a:lnSpc>
               <a:buNone/>
             </a:pPr>
             <a:r>
-              <a:rPr lang="en-US" sz="1250" dirty="0">
+              <a:rPr lang="en-US" sz="1800" dirty="0">
                 <a:solidFill>
                   <a:srgbClr val="5B6B77"/>
                 </a:solidFill>
@@ -8151,7 +8151,7 @@
               </a:rPr>
               <a:t>Desmagnetitzar el suport. Només funciona en suports magnètics (discs durs, cintes) i tampoc permet reutilitzar-lo després.</a:t>
             </a:r>
-            <a:endParaRPr lang="en-US" sz="1250" dirty="0"/>
+            <a:endParaRPr lang="en-US" sz="1800" dirty="0"/>
           </a:p>
         </p:txBody>
       </p:sp>
@@ -8163,8 +8163,8 @@
         </p:nvSpPr>
         <p:spPr>
           <a:xfrm>
-            <a:off x="8130388" y="1737360"/>
-            <a:ext cx="3429000" cy="3840480"/>
+            <a:off x="8130388" y="1661160"/>
+            <a:ext cx="3429000" cy="4096511"/>
           </a:xfrm>
           <a:prstGeom prst="roundRect">
             <a:avLst>
@@ -8201,7 +8201,7 @@
         </p:nvSpPr>
         <p:spPr>
           <a:xfrm>
-            <a:off x="8450428" y="2057400"/>
+            <a:off x="8514436" y="2045208"/>
             <a:ext cx="731520" cy="731520"/>
           </a:xfrm>
           <a:prstGeom prst="ellipse">
@@ -8233,7 +8233,7 @@
         </p:blipFill>
         <p:spPr>
           <a:xfrm>
-            <a:off x="8633308" y="2240280"/>
+            <a:off x="8697316" y="2228088"/>
             <a:ext cx="365760" cy="365760"/>
           </a:xfrm>
           <a:prstGeom prst="rect">
@@ -8249,8 +8249,8 @@
         </p:nvSpPr>
         <p:spPr>
           <a:xfrm>
-            <a:off x="8404708" y="2971800"/>
-            <a:ext cx="2880360" cy="731520"/>
+            <a:off x="8514436" y="3005328"/>
+            <a:ext cx="2660904" cy="335280"/>
           </a:xfrm>
           <a:prstGeom prst="rect">
             <a:avLst/>
@@ -8266,7 +8266,7 @@
               <a:buNone/>
             </a:pPr>
             <a:r>
-              <a:rPr lang="en-US" sz="1700" b="1" dirty="0">
+              <a:rPr lang="en-US" sz="2200" b="1" dirty="0">
                 <a:solidFill>
                   <a:srgbClr val="16242E"/>
                 </a:solidFill>
@@ -8276,7 +8276,7 @@
               </a:rPr>
               <a:t>Sobrescriptura</a:t>
             </a:r>
-            <a:endParaRPr lang="en-US" sz="1700" dirty="0"/>
+            <a:endParaRPr lang="en-US" sz="2200" dirty="0"/>
           </a:p>
         </p:txBody>
       </p:sp>
@@ -8288,8 +8288,8 @@
         </p:nvSpPr>
         <p:spPr>
           <a:xfrm>
-            <a:off x="8404708" y="3611880"/>
-            <a:ext cx="2880360" cy="1828800"/>
+            <a:off x="8514436" y="3477768"/>
+            <a:ext cx="2660904" cy="1895856"/>
           </a:xfrm>
           <a:prstGeom prst="rect">
             <a:avLst/>
@@ -8303,12 +8303,12 @@
           <a:p>
             <a:pPr indent="0" marL="0">
               <a:lnSpc>
-                <a:spcPts val="1600"/>
+                <a:spcPts val="2488"/>
               </a:lnSpc>
               <a:buNone/>
             </a:pPr>
             <a:r>
-              <a:rPr lang="en-US" sz="1250" dirty="0">
+              <a:rPr lang="en-US" sz="1800" dirty="0">
                 <a:solidFill>
                   <a:srgbClr val="5B6B77"/>
                 </a:solidFill>
@@ -8318,7 +8318,7 @@
               </a:rPr>
               <a:t>Sobreescriure la informació amb dades aleatòries. Funciona en suports magnètics i flaix (SSD, USB, targetes SD) i sí que permet reutilitzar el dispositiu.</a:t>
             </a:r>
-            <a:endParaRPr lang="en-US" sz="1250" dirty="0"/>
+            <a:endParaRPr lang="en-US" sz="1800" dirty="0"/>
           </a:p>
         </p:txBody>
       </p:sp>

</xml_diff>

<commit_message>
RA2-AA1: la diapositiva 6 explicita la diferència entre servidors i sistemes d'emmagatzematge redundants
Co-Authored-By: Claude Opus 5.5 <noreply@anthropic.com>
Claude-Session: https://claude.ai/code/session_01BodJZ9PsepvknsFhsdyYkP
</commit_message>
<xml_diff>
--- a/RA2 - Emmagatzematge i copies de seguretat/AA1 - Protegint les dades/RA2_AA1_Protegint_les_dades.pptx
+++ b/RA2 - Emmagatzematge i copies de seguretat/AA1 - Protegint les dades/RA2_AA1_Protegint_les_dades.pptx
@@ -6461,7 +6461,7 @@
         <p:spPr>
           <a:xfrm>
             <a:off x="655168" y="1661160"/>
-            <a:ext cx="5212080" cy="3968496"/>
+            <a:ext cx="5212080" cy="4745736"/>
           </a:xfrm>
           <a:prstGeom prst="roundRect">
             <a:avLst>
@@ -6586,7 +6586,7 @@
         <p:spPr>
           <a:xfrm>
             <a:off x="1039216" y="3069336"/>
-            <a:ext cx="4443984" cy="2176272"/>
+            <a:ext cx="4443984" cy="2953512"/>
           </a:xfrm>
           <a:prstGeom prst="rect">
             <a:avLst/>
@@ -6617,6 +6617,29 @@
             </a:r>
             <a:endParaRPr lang="en-US" sz="1800" dirty="0"/>
           </a:p>
+          <a:p>
+            <a:pPr indent="0" marL="0">
+              <a:lnSpc>
+                <a:spcPts val="2448"/>
+              </a:lnSpc>
+              <a:spcBef>
+                <a:spcPts val="1200"/>
+              </a:spcBef>
+              <a:buNone/>
+            </a:pPr>
+            <a:r>
+              <a:rPr lang="en-US" sz="1800" dirty="0" b="1">
+                <a:solidFill>
+                  <a:srgbClr val="142230"/>
+                </a:solidFill>
+                <a:latin typeface="Calibri" pitchFamily="34" charset="0"/>
+                <a:ea typeface="Calibri" pitchFamily="34" charset="-122"/>
+                <a:cs typeface="Calibri" pitchFamily="34" charset="-120"/>
+              </a:rPr>
+              <a:t>Duplica el servidor sencer: protegeix d'una avaria de qualsevol peça.</a:t>
+            </a:r>
+            <a:endParaRPr lang="en-US" sz="1800" dirty="0"/>
+          </a:p>
         </p:txBody>
       </p:sp>
       <p:sp>
@@ -6628,7 +6651,7 @@
         <p:spPr>
           <a:xfrm>
             <a:off x="6324448" y="1661160"/>
-            <a:ext cx="5212080" cy="3968496"/>
+            <a:ext cx="5212080" cy="4745736"/>
           </a:xfrm>
           <a:prstGeom prst="roundRect">
             <a:avLst>
@@ -6753,7 +6776,7 @@
         <p:spPr>
           <a:xfrm>
             <a:off x="6708496" y="3343656"/>
-            <a:ext cx="4443984" cy="1865376"/>
+            <a:ext cx="4443984" cy="2642616"/>
           </a:xfrm>
           <a:prstGeom prst="rect">
             <a:avLst/>
@@ -6781,6 +6804,29 @@
                 <a:cs typeface="Calibri" pitchFamily="34" charset="-120"/>
               </a:rPr>
               <a:t>Tenir més d'un sistema d'emmagatzematge amb la mateixa informació. Aquesta és l'estratègia que SEMPRE s'aplica: permet que, davant l'avaria d'un disc o SSD, el sistema continuï funcionant sense pèrdua de dades. En parlarem en detall al proper apartat (RAID).</a:t>
+            </a:r>
+            <a:endParaRPr lang="en-US" sz="1800" dirty="0"/>
+          </a:p>
+          <a:p>
+            <a:pPr indent="0" marL="0">
+              <a:lnSpc>
+                <a:spcPts val="2448"/>
+              </a:lnSpc>
+              <a:spcBef>
+                <a:spcPts val="1200"/>
+              </a:spcBef>
+              <a:buNone/>
+            </a:pPr>
+            <a:r>
+              <a:rPr lang="en-US" sz="1800" dirty="0" b="1">
+                <a:solidFill>
+                  <a:srgbClr val="142230"/>
+                </a:solidFill>
+                <a:latin typeface="Calibri" pitchFamily="34" charset="0"/>
+                <a:ea typeface="Calibri" pitchFamily="34" charset="-122"/>
+                <a:cs typeface="Calibri" pitchFamily="34" charset="-120"/>
+              </a:rPr>
+              <a:t>Duplica només els discos: si falla la placa o la font, el servei s'atura.</a:t>
             </a:r>
             <a:endParaRPr lang="en-US" sz="1800" dirty="0"/>
           </a:p>

</xml_diff>